<commit_message>
Publicare 2026-10-18 (versiuni: 2026.1.0, 2026.1.1)
</commit_message>
<xml_diff>
--- a/EPS_I/ro/fisiere/C01.pptx
+++ b/EPS_I/ro/fisiere/C01.pptx
@@ -4906,6 +4906,10 @@
             <a:prstDash val="solid"/>
           </a:ln>
         </p:spPr>
+        <p:txBody>
+          <a:bodyPr/>
+          <a:p/>
+        </p:txBody>
       </p:sp>
       <p:sp>
         <p:nvSpPr>
@@ -5048,6 +5052,10 @@
             <a:prstDash val="solid"/>
           </a:ln>
         </p:spPr>
+        <p:txBody>
+          <a:bodyPr/>
+          <a:p/>
+        </p:txBody>
       </p:sp>
       <p:sp>
         <p:nvSpPr>
@@ -5153,6 +5161,10 @@
             <a:prstDash val="solid"/>
           </a:ln>
         </p:spPr>
+        <p:txBody>
+          <a:bodyPr/>
+          <a:p/>
+        </p:txBody>
       </p:sp>
       <p:sp>
         <p:nvSpPr>
@@ -5180,6 +5192,10 @@
             <a:prstDash val="solid"/>
           </a:ln>
         </p:spPr>
+        <p:txBody>
+          <a:bodyPr/>
+          <a:p/>
+        </p:txBody>
       </p:sp>
       <p:sp>
         <p:nvSpPr>
@@ -5212,6 +5228,10 @@
             </a:outerShdw>
           </a:effectLst>
         </p:spPr>
+        <p:txBody>
+          <a:bodyPr/>
+          <a:p/>
+        </p:txBody>
       </p:sp>
       <p:sp>
         <p:nvSpPr>
@@ -5276,6 +5296,10 @@
             <a:prstDash val="solid"/>
           </a:ln>
         </p:spPr>
+        <p:txBody>
+          <a:bodyPr/>
+          <a:p/>
+        </p:txBody>
       </p:sp>
       <p:sp>
         <p:nvSpPr>
@@ -5301,6 +5325,10 @@
             <a:prstDash val="solid"/>
           </a:ln>
         </p:spPr>
+        <p:txBody>
+          <a:bodyPr/>
+          <a:p/>
+        </p:txBody>
       </p:sp>
       <p:sp>
         <p:nvSpPr>
@@ -5326,6 +5354,10 @@
             <a:prstDash val="solid"/>
           </a:ln>
         </p:spPr>
+        <p:txBody>
+          <a:bodyPr/>
+          <a:p/>
+        </p:txBody>
       </p:sp>
       <p:sp>
         <p:nvSpPr>
@@ -5351,6 +5383,10 @@
             <a:prstDash val="solid"/>
           </a:ln>
         </p:spPr>
+        <p:txBody>
+          <a:bodyPr/>
+          <a:p/>
+        </p:txBody>
       </p:sp>
       <p:sp>
         <p:nvSpPr>
@@ -5376,6 +5412,10 @@
             <a:prstDash val="solid"/>
           </a:ln>
         </p:spPr>
+        <p:txBody>
+          <a:bodyPr/>
+          <a:p/>
+        </p:txBody>
       </p:sp>
       <p:sp>
         <p:nvSpPr>
@@ -5401,6 +5441,10 @@
             <a:prstDash val="solid"/>
           </a:ln>
         </p:spPr>
+        <p:txBody>
+          <a:bodyPr/>
+          <a:p/>
+        </p:txBody>
       </p:sp>
       <p:sp>
         <p:nvSpPr>
@@ -5426,6 +5470,10 @@
             <a:prstDash val="solid"/>
           </a:ln>
         </p:spPr>
+        <p:txBody>
+          <a:bodyPr/>
+          <a:p/>
+        </p:txBody>
       </p:sp>
       <p:sp>
         <p:nvSpPr>
@@ -5451,6 +5499,10 @@
             <a:prstDash val="solid"/>
           </a:ln>
         </p:spPr>
+        <p:txBody>
+          <a:bodyPr/>
+          <a:p/>
+        </p:txBody>
       </p:sp>
       <p:sp>
         <p:nvSpPr>
@@ -5476,6 +5528,10 @@
             <a:prstDash val="solid"/>
           </a:ln>
         </p:spPr>
+        <p:txBody>
+          <a:bodyPr/>
+          <a:p/>
+        </p:txBody>
       </p:sp>
       <p:sp>
         <p:nvSpPr>
@@ -5501,6 +5557,10 @@
             <a:prstDash val="solid"/>
           </a:ln>
         </p:spPr>
+        <p:txBody>
+          <a:bodyPr/>
+          <a:p/>
+        </p:txBody>
       </p:sp>
       <p:sp>
         <p:nvSpPr>
@@ -5526,6 +5586,10 @@
             <a:prstDash val="solid"/>
           </a:ln>
         </p:spPr>
+        <p:txBody>
+          <a:bodyPr/>
+          <a:p/>
+        </p:txBody>
       </p:sp>
       <p:sp>
         <p:nvSpPr>
@@ -5551,6 +5615,10 @@
             <a:prstDash val="solid"/>
           </a:ln>
         </p:spPr>
+        <p:txBody>
+          <a:bodyPr/>
+          <a:p/>
+        </p:txBody>
       </p:sp>
       <p:sp>
         <p:nvSpPr>
@@ -5576,6 +5644,10 @@
             <a:prstDash val="solid"/>
           </a:ln>
         </p:spPr>
+        <p:txBody>
+          <a:bodyPr/>
+          <a:p/>
+        </p:txBody>
       </p:sp>
       <p:sp>
         <p:nvSpPr>
@@ -5601,6 +5673,10 @@
             <a:prstDash val="solid"/>
           </a:ln>
         </p:spPr>
+        <p:txBody>
+          <a:bodyPr/>
+          <a:p/>
+        </p:txBody>
       </p:sp>
       <p:sp>
         <p:nvSpPr>
@@ -5626,6 +5702,10 @@
             <a:prstDash val="solid"/>
           </a:ln>
         </p:spPr>
+        <p:txBody>
+          <a:bodyPr/>
+          <a:p/>
+        </p:txBody>
       </p:sp>
       <p:sp>
         <p:nvSpPr>
@@ -5651,6 +5731,10 @@
             <a:prstDash val="solid"/>
           </a:ln>
         </p:spPr>
+        <p:txBody>
+          <a:bodyPr/>
+          <a:p/>
+        </p:txBody>
       </p:sp>
       <p:sp>
         <p:nvSpPr>
@@ -5676,6 +5760,10 @@
             <a:prstDash val="solid"/>
           </a:ln>
         </p:spPr>
+        <p:txBody>
+          <a:bodyPr/>
+          <a:p/>
+        </p:txBody>
       </p:sp>
       <p:sp>
         <p:nvSpPr>
@@ -5701,6 +5789,10 @@
             <a:prstDash val="solid"/>
           </a:ln>
         </p:spPr>
+        <p:txBody>
+          <a:bodyPr/>
+          <a:p/>
+        </p:txBody>
       </p:sp>
       <p:sp>
         <p:nvSpPr>
@@ -5726,6 +5818,10 @@
             <a:prstDash val="solid"/>
           </a:ln>
         </p:spPr>
+        <p:txBody>
+          <a:bodyPr/>
+          <a:p/>
+        </p:txBody>
       </p:sp>
       <p:sp>
         <p:nvSpPr>
@@ -5751,6 +5847,10 @@
             <a:prstDash val="solid"/>
           </a:ln>
         </p:spPr>
+        <p:txBody>
+          <a:bodyPr/>
+          <a:p/>
+        </p:txBody>
       </p:sp>
       <p:sp>
         <p:nvSpPr>
@@ -5776,6 +5876,10 @@
             <a:prstDash val="solid"/>
           </a:ln>
         </p:spPr>
+        <p:txBody>
+          <a:bodyPr/>
+          <a:p/>
+        </p:txBody>
       </p:sp>
       <p:sp>
         <p:nvSpPr>
@@ -5801,6 +5905,10 @@
             <a:prstDash val="solid"/>
           </a:ln>
         </p:spPr>
+        <p:txBody>
+          <a:bodyPr/>
+          <a:p/>
+        </p:txBody>
       </p:sp>
       <p:sp>
         <p:nvSpPr>
@@ -5826,6 +5934,10 @@
             <a:prstDash val="solid"/>
           </a:ln>
         </p:spPr>
+        <p:txBody>
+          <a:bodyPr/>
+          <a:p/>
+        </p:txBody>
       </p:sp>
       <p:sp>
         <p:nvSpPr>
@@ -5851,6 +5963,10 @@
             <a:prstDash val="solid"/>
           </a:ln>
         </p:spPr>
+        <p:txBody>
+          <a:bodyPr/>
+          <a:p/>
+        </p:txBody>
       </p:sp>
       <p:sp>
         <p:nvSpPr>
@@ -5876,6 +5992,10 @@
             <a:prstDash val="solid"/>
           </a:ln>
         </p:spPr>
+        <p:txBody>
+          <a:bodyPr/>
+          <a:p/>
+        </p:txBody>
       </p:sp>
     </p:spTree>
   </p:cSld>
@@ -6013,6 +6133,10 @@
             <a:prstDash val="solid"/>
           </a:ln>
         </p:spPr>
+        <p:txBody>
+          <a:bodyPr/>
+          <a:p/>
+        </p:txBody>
       </p:sp>
       <p:sp>
         <p:nvSpPr>
@@ -6143,6 +6267,10 @@
             <a:prstDash val="solid"/>
           </a:ln>
         </p:spPr>
+        <p:txBody>
+          <a:bodyPr/>
+          <a:p/>
+        </p:txBody>
       </p:sp>
       <p:sp>
         <p:nvSpPr>
@@ -6347,6 +6475,10 @@
             <a:prstDash val="solid"/>
           </a:ln>
         </p:spPr>
+        <p:txBody>
+          <a:bodyPr/>
+          <a:p/>
+        </p:txBody>
       </p:sp>
       <p:sp>
         <p:nvSpPr>
@@ -6420,7 +6552,7 @@
                 <a:ea typeface="Palatino Linotype" pitchFamily="34" charset="-122"/>
                 <a:cs typeface="Palatino Linotype" pitchFamily="34" charset="-120"/>
               </a:rPr>
-              <a:t>Pacientul programat la rezonanța magnetică</a:t>
+              <a:t>Pacientul la examenul prin rezonanță magnetică (RMN)</a:t>
             </a:r>
             <a:endParaRPr lang="en-US" sz="3100" dirty="0"/>
           </a:p>
@@ -6452,6 +6584,10 @@
             <a:prstDash val="solid"/>
           </a:ln>
         </p:spPr>
+        <p:txBody>
+          <a:bodyPr/>
+          <a:p/>
+        </p:txBody>
       </p:sp>
       <p:sp>
         <p:nvSpPr>
@@ -6603,6 +6739,10 @@
             <a:prstDash val="solid"/>
           </a:ln>
         </p:spPr>
+        <p:txBody>
+          <a:bodyPr/>
+          <a:p/>
+        </p:txBody>
       </p:sp>
       <p:sp>
         <p:nvSpPr>
@@ -6901,6 +7041,10 @@
             <a:prstDash val="solid"/>
           </a:ln>
         </p:spPr>
+        <p:txBody>
+          <a:bodyPr/>
+          <a:p/>
+        </p:txBody>
       </p:sp>
       <p:sp>
         <p:nvSpPr>
@@ -7004,6 +7148,10 @@
             <a:prstDash val="solid"/>
           </a:ln>
         </p:spPr>
+        <p:txBody>
+          <a:bodyPr/>
+          <a:p/>
+        </p:txBody>
       </p:sp>
       <p:sp>
         <p:nvSpPr>
@@ -7109,6 +7257,10 @@
             <a:prstDash val="solid"/>
           </a:ln>
         </p:spPr>
+        <p:txBody>
+          <a:bodyPr/>
+          <a:p/>
+        </p:txBody>
       </p:sp>
       <p:sp>
         <p:nvSpPr>
@@ -7175,6 +7327,10 @@
             <a:prstDash val="solid"/>
           </a:ln>
         </p:spPr>
+        <p:txBody>
+          <a:bodyPr/>
+          <a:p/>
+        </p:txBody>
       </p:sp>
       <p:sp>
         <p:nvSpPr>
@@ -7273,6 +7429,10 @@
             <a:prstDash val="solid"/>
           </a:ln>
         </p:spPr>
+        <p:txBody>
+          <a:bodyPr/>
+          <a:p/>
+        </p:txBody>
       </p:sp>
       <p:sp>
         <p:nvSpPr>
@@ -7534,6 +7694,10 @@
             <a:prstDash val="solid"/>
           </a:ln>
         </p:spPr>
+        <p:txBody>
+          <a:bodyPr/>
+          <a:p/>
+        </p:txBody>
       </p:sp>
       <p:sp>
         <p:nvSpPr>
@@ -7600,6 +7764,10 @@
             <a:prstDash val="solid"/>
           </a:ln>
         </p:spPr>
+        <p:txBody>
+          <a:bodyPr/>
+          <a:p/>
+        </p:txBody>
       </p:sp>
       <p:sp>
         <p:nvSpPr>
@@ -7666,6 +7834,10 @@
             <a:prstDash val="solid"/>
           </a:ln>
         </p:spPr>
+        <p:txBody>
+          <a:bodyPr/>
+          <a:p/>
+        </p:txBody>
       </p:sp>
       <p:sp>
         <p:nvSpPr>
@@ -7732,6 +7904,10 @@
             <a:prstDash val="solid"/>
           </a:ln>
         </p:spPr>
+        <p:txBody>
+          <a:bodyPr/>
+          <a:p/>
+        </p:txBody>
       </p:sp>
       <p:sp>
         <p:nvSpPr>
@@ -7798,6 +7974,10 @@
             <a:prstDash val="solid"/>
           </a:ln>
         </p:spPr>
+        <p:txBody>
+          <a:bodyPr/>
+          <a:p/>
+        </p:txBody>
       </p:sp>
       <p:sp>
         <p:nvSpPr>
@@ -7974,6 +8154,10 @@
             <a:prstDash val="solid"/>
           </a:ln>
         </p:spPr>
+        <p:txBody>
+          <a:bodyPr/>
+          <a:p/>
+        </p:txBody>
       </p:sp>
       <p:sp>
         <p:nvSpPr>
@@ -7999,6 +8183,10 @@
             <a:prstDash val="solid"/>
           </a:ln>
         </p:spPr>
+        <p:txBody>
+          <a:bodyPr/>
+          <a:p/>
+        </p:txBody>
       </p:sp>
       <p:sp>
         <p:nvSpPr>
@@ -8143,6 +8331,10 @@
             <a:prstDash val="solid"/>
           </a:ln>
         </p:spPr>
+        <p:txBody>
+          <a:bodyPr/>
+          <a:p/>
+        </p:txBody>
       </p:sp>
       <p:sp>
         <p:nvSpPr>
@@ -8168,6 +8360,10 @@
             <a:prstDash val="solid"/>
           </a:ln>
         </p:spPr>
+        <p:txBody>
+          <a:bodyPr/>
+          <a:p/>
+        </p:txBody>
       </p:sp>
       <p:sp>
         <p:nvSpPr>
@@ -8312,6 +8508,10 @@
             <a:prstDash val="solid"/>
           </a:ln>
         </p:spPr>
+        <p:txBody>
+          <a:bodyPr/>
+          <a:p/>
+        </p:txBody>
       </p:sp>
       <p:sp>
         <p:nvSpPr>
@@ -8337,6 +8537,10 @@
             <a:prstDash val="solid"/>
           </a:ln>
         </p:spPr>
+        <p:txBody>
+          <a:bodyPr/>
+          <a:p/>
+        </p:txBody>
       </p:sp>
       <p:sp>
         <p:nvSpPr>
@@ -8481,6 +8685,10 @@
             <a:prstDash val="solid"/>
           </a:ln>
         </p:spPr>
+        <p:txBody>
+          <a:bodyPr/>
+          <a:p/>
+        </p:txBody>
       </p:sp>
       <p:sp>
         <p:nvSpPr>
@@ -8506,6 +8714,10 @@
             <a:prstDash val="solid"/>
           </a:ln>
         </p:spPr>
+        <p:txBody>
+          <a:bodyPr/>
+          <a:p/>
+        </p:txBody>
       </p:sp>
       <p:sp>
         <p:nvSpPr>
@@ -8650,6 +8862,10 @@
             <a:prstDash val="solid"/>
           </a:ln>
         </p:spPr>
+        <p:txBody>
+          <a:bodyPr/>
+          <a:p/>
+        </p:txBody>
       </p:sp>
       <p:sp>
         <p:nvSpPr>
@@ -8675,6 +8891,10 @@
             <a:prstDash val="solid"/>
           </a:ln>
         </p:spPr>
+        <p:txBody>
+          <a:bodyPr/>
+          <a:p/>
+        </p:txBody>
       </p:sp>
       <p:sp>
         <p:nvSpPr>
@@ -8819,6 +9039,10 @@
             <a:prstDash val="solid"/>
           </a:ln>
         </p:spPr>
+        <p:txBody>
+          <a:bodyPr/>
+          <a:p/>
+        </p:txBody>
       </p:sp>
       <p:sp>
         <p:nvSpPr>
@@ -8844,6 +9068,10 @@
             <a:prstDash val="solid"/>
           </a:ln>
         </p:spPr>
+        <p:txBody>
+          <a:bodyPr/>
+          <a:p/>
+        </p:txBody>
       </p:sp>
       <p:sp>
         <p:nvSpPr>
@@ -9059,6 +9287,10 @@
             <a:prstDash val="solid"/>
           </a:ln>
         </p:spPr>
+        <p:txBody>
+          <a:bodyPr/>
+          <a:p/>
+        </p:txBody>
       </p:sp>
       <p:sp>
         <p:nvSpPr>
@@ -9208,6 +9440,10 @@
             </a:outerShdw>
           </a:effectLst>
         </p:spPr>
+        <p:txBody>
+          <a:bodyPr/>
+          <a:p/>
+        </p:txBody>
       </p:sp>
       <p:sp>
         <p:nvSpPr>
@@ -9423,6 +9659,10 @@
             <a:prstDash val="solid"/>
           </a:ln>
         </p:spPr>
+        <p:txBody>
+          <a:bodyPr/>
+          <a:p/>
+        </p:txBody>
       </p:sp>
       <p:sp>
         <p:nvSpPr>
@@ -9448,6 +9688,10 @@
             <a:prstDash val="solid"/>
           </a:ln>
         </p:spPr>
+        <p:txBody>
+          <a:bodyPr/>
+          <a:p/>
+        </p:txBody>
       </p:sp>
       <p:sp>
         <p:nvSpPr>
@@ -9514,6 +9758,10 @@
             <a:prstDash val="solid"/>
           </a:ln>
         </p:spPr>
+        <p:txBody>
+          <a:bodyPr/>
+          <a:p/>
+        </p:txBody>
       </p:sp>
       <p:sp>
         <p:nvSpPr>
@@ -9619,6 +9867,10 @@
             <a:prstDash val="solid"/>
           </a:ln>
         </p:spPr>
+        <p:txBody>
+          <a:bodyPr/>
+          <a:p/>
+        </p:txBody>
       </p:sp>
       <p:sp>
         <p:nvSpPr>
@@ -9724,6 +9976,10 @@
             <a:prstDash val="solid"/>
           </a:ln>
         </p:spPr>
+        <p:txBody>
+          <a:bodyPr/>
+          <a:p/>
+        </p:txBody>
       </p:sp>
       <p:sp>
         <p:nvSpPr>
@@ -9937,6 +10193,10 @@
             <a:prstDash val="solid"/>
           </a:ln>
         </p:spPr>
+        <p:txBody>
+          <a:bodyPr/>
+          <a:p/>
+        </p:txBody>
       </p:sp>
       <p:sp>
         <p:nvSpPr>
@@ -9957,6 +10217,10 @@
           </a:solidFill>
           <a:ln/>
         </p:spPr>
+        <p:txBody>
+          <a:bodyPr/>
+          <a:p/>
+        </p:txBody>
       </p:sp>
       <p:sp>
         <p:nvSpPr>
@@ -10094,6 +10358,10 @@
           </a:solidFill>
           <a:ln/>
         </p:spPr>
+        <p:txBody>
+          <a:bodyPr/>
+          <a:p/>
+        </p:txBody>
       </p:sp>
       <p:sp>
         <p:nvSpPr>
@@ -10231,6 +10499,10 @@
           </a:solidFill>
           <a:ln/>
         </p:spPr>
+        <p:txBody>
+          <a:bodyPr/>
+          <a:p/>
+        </p:txBody>
       </p:sp>
       <p:sp>
         <p:nvSpPr>
@@ -10368,6 +10640,10 @@
           </a:solidFill>
           <a:ln/>
         </p:spPr>
+        <p:txBody>
+          <a:bodyPr/>
+          <a:p/>
+        </p:txBody>
       </p:sp>
       <p:sp>
         <p:nvSpPr>
@@ -10505,6 +10781,10 @@
           </a:solidFill>
           <a:ln/>
         </p:spPr>
+        <p:txBody>
+          <a:bodyPr/>
+          <a:p/>
+        </p:txBody>
       </p:sp>
       <p:sp>
         <p:nvSpPr>
@@ -10649,6 +10929,10 @@
             <a:prstDash val="solid"/>
           </a:ln>
         </p:spPr>
+        <p:txBody>
+          <a:bodyPr/>
+          <a:p/>
+        </p:txBody>
       </p:sp>
       <p:sp>
         <p:nvSpPr>
@@ -10864,6 +11148,10 @@
             <a:prstDash val="solid"/>
           </a:ln>
         </p:spPr>
+        <p:txBody>
+          <a:bodyPr/>
+          <a:p/>
+        </p:txBody>
       </p:sp>
       <p:sp>
         <p:nvSpPr>
@@ -10889,6 +11177,10 @@
             <a:prstDash val="solid"/>
           </a:ln>
         </p:spPr>
+        <p:txBody>
+          <a:bodyPr/>
+          <a:p/>
+        </p:txBody>
       </p:sp>
       <p:sp>
         <p:nvSpPr>
@@ -10994,6 +11286,10 @@
             <a:prstDash val="solid"/>
           </a:ln>
         </p:spPr>
+        <p:txBody>
+          <a:bodyPr/>
+          <a:p/>
+        </p:txBody>
       </p:sp>
       <p:sp>
         <p:nvSpPr>
@@ -11019,6 +11315,10 @@
             <a:prstDash val="solid"/>
           </a:ln>
         </p:spPr>
+        <p:txBody>
+          <a:bodyPr/>
+          <a:p/>
+        </p:txBody>
       </p:sp>
       <p:sp>
         <p:nvSpPr>
@@ -11124,6 +11424,10 @@
             <a:prstDash val="solid"/>
           </a:ln>
         </p:spPr>
+        <p:txBody>
+          <a:bodyPr/>
+          <a:p/>
+        </p:txBody>
       </p:sp>
       <p:sp>
         <p:nvSpPr>
@@ -11149,6 +11453,10 @@
             <a:prstDash val="solid"/>
           </a:ln>
         </p:spPr>
+        <p:txBody>
+          <a:bodyPr/>
+          <a:p/>
+        </p:txBody>
       </p:sp>
       <p:sp>
         <p:nvSpPr>
@@ -11559,6 +11867,10 @@
             <a:prstDash val="solid"/>
           </a:ln>
         </p:spPr>
+        <p:txBody>
+          <a:bodyPr/>
+          <a:p/>
+        </p:txBody>
       </p:sp>
       <p:sp>
         <p:nvSpPr>
@@ -11586,6 +11898,10 @@
             <a:prstDash val="solid"/>
           </a:ln>
         </p:spPr>
+        <p:txBody>
+          <a:bodyPr/>
+          <a:p/>
+        </p:txBody>
       </p:sp>
       <p:sp>
         <p:nvSpPr>
@@ -11652,6 +11968,10 @@
             <a:prstDash val="solid"/>
           </a:ln>
         </p:spPr>
+        <p:txBody>
+          <a:bodyPr/>
+          <a:p/>
+        </p:txBody>
       </p:sp>
       <p:sp>
         <p:nvSpPr>
@@ -11677,6 +11997,10 @@
             <a:prstDash val="solid"/>
           </a:ln>
         </p:spPr>
+        <p:txBody>
+          <a:bodyPr/>
+          <a:p/>
+        </p:txBody>
       </p:sp>
       <p:sp>
         <p:nvSpPr>
@@ -11890,6 +12214,10 @@
             <a:prstDash val="solid"/>
           </a:ln>
         </p:spPr>
+        <p:txBody>
+          <a:bodyPr/>
+          <a:p/>
+        </p:txBody>
       </p:sp>
       <p:sp>
         <p:nvSpPr>
@@ -11954,6 +12282,10 @@
             <a:prstDash val="solid"/>
           </a:ln>
         </p:spPr>
+        <p:txBody>
+          <a:bodyPr/>
+          <a:p/>
+        </p:txBody>
       </p:sp>
       <p:sp>
         <p:nvSpPr>
@@ -12018,6 +12350,10 @@
             <a:prstDash val="solid"/>
           </a:ln>
         </p:spPr>
+        <p:txBody>
+          <a:bodyPr/>
+          <a:p/>
+        </p:txBody>
       </p:sp>
       <p:sp>
         <p:nvSpPr>
@@ -12082,6 +12418,10 @@
             <a:prstDash val="solid"/>
           </a:ln>
         </p:spPr>
+        <p:txBody>
+          <a:bodyPr/>
+          <a:p/>
+        </p:txBody>
       </p:sp>
       <p:sp>
         <p:nvSpPr>
@@ -12146,6 +12486,10 @@
             <a:prstDash val="solid"/>
           </a:ln>
         </p:spPr>
+        <p:txBody>
+          <a:bodyPr/>
+          <a:p/>
+        </p:txBody>
       </p:sp>
       <p:sp>
         <p:nvSpPr>
@@ -12210,6 +12554,10 @@
             <a:prstDash val="solid"/>
           </a:ln>
         </p:spPr>
+        <p:txBody>
+          <a:bodyPr/>
+          <a:p/>
+        </p:txBody>
       </p:sp>
       <p:sp>
         <p:nvSpPr>
@@ -12274,6 +12622,10 @@
             <a:prstDash val="solid"/>
           </a:ln>
         </p:spPr>
+        <p:txBody>
+          <a:bodyPr/>
+          <a:p/>
+        </p:txBody>
       </p:sp>
       <p:sp>
         <p:nvSpPr>
@@ -12379,6 +12731,10 @@
             <a:prstDash val="solid"/>
           </a:ln>
         </p:spPr>
+        <p:txBody>
+          <a:bodyPr/>
+          <a:p/>
+        </p:txBody>
       </p:sp>
       <p:sp>
         <p:nvSpPr>
@@ -12539,6 +12895,10 @@
             <a:prstDash val="solid"/>
           </a:ln>
         </p:spPr>
+        <p:txBody>
+          <a:bodyPr/>
+          <a:p/>
+        </p:txBody>
       </p:sp>
       <p:sp>
         <p:nvSpPr>
@@ -12644,6 +13004,10 @@
             <a:prstDash val="solid"/>
           </a:ln>
         </p:spPr>
+        <p:txBody>
+          <a:bodyPr/>
+          <a:p/>
+        </p:txBody>
       </p:sp>
       <p:sp>
         <p:nvSpPr>
@@ -12669,6 +13033,10 @@
             <a:prstDash val="solid"/>
           </a:ln>
         </p:spPr>
+        <p:txBody>
+          <a:bodyPr/>
+          <a:p/>
+        </p:txBody>
       </p:sp>
       <p:sp>
         <p:nvSpPr>
@@ -12774,6 +13142,10 @@
             <a:prstDash val="solid"/>
           </a:ln>
         </p:spPr>
+        <p:txBody>
+          <a:bodyPr/>
+          <a:p/>
+        </p:txBody>
       </p:sp>
       <p:sp>
         <p:nvSpPr>
@@ -12799,6 +13171,10 @@
             <a:prstDash val="solid"/>
           </a:ln>
         </p:spPr>
+        <p:txBody>
+          <a:bodyPr/>
+          <a:p/>
+        </p:txBody>
       </p:sp>
       <p:sp>
         <p:nvSpPr>
@@ -12904,6 +13280,10 @@
             <a:prstDash val="solid"/>
           </a:ln>
         </p:spPr>
+        <p:txBody>
+          <a:bodyPr/>
+          <a:p/>
+        </p:txBody>
       </p:sp>
       <p:sp>
         <p:nvSpPr>
@@ -12929,6 +13309,10 @@
             <a:prstDash val="solid"/>
           </a:ln>
         </p:spPr>
+        <p:txBody>
+          <a:bodyPr/>
+          <a:p/>
+        </p:txBody>
       </p:sp>
       <p:sp>
         <p:nvSpPr>
@@ -13144,6 +13528,10 @@
             <a:prstDash val="solid"/>
           </a:ln>
         </p:spPr>
+        <p:txBody>
+          <a:bodyPr/>
+          <a:p/>
+        </p:txBody>
       </p:sp>
       <p:sp>
         <p:nvSpPr>
@@ -13288,6 +13676,10 @@
             <a:prstDash val="solid"/>
           </a:ln>
         </p:spPr>
+        <p:txBody>
+          <a:bodyPr/>
+          <a:p/>
+        </p:txBody>
       </p:sp>
       <p:sp>
         <p:nvSpPr>
@@ -13308,6 +13700,10 @@
           </a:solidFill>
           <a:ln/>
         </p:spPr>
+        <p:txBody>
+          <a:bodyPr/>
+          <a:p/>
+        </p:txBody>
       </p:sp>
       <p:sp>
         <p:nvSpPr>
@@ -13413,6 +13809,10 @@
             <a:prstDash val="solid"/>
           </a:ln>
         </p:spPr>
+        <p:txBody>
+          <a:bodyPr/>
+          <a:p/>
+        </p:txBody>
       </p:sp>
       <p:sp>
         <p:nvSpPr>
@@ -13433,6 +13833,10 @@
           </a:solidFill>
           <a:ln/>
         </p:spPr>
+        <p:txBody>
+          <a:bodyPr/>
+          <a:p/>
+        </p:txBody>
       </p:sp>
       <p:sp>
         <p:nvSpPr>
@@ -13538,6 +13942,10 @@
             <a:prstDash val="solid"/>
           </a:ln>
         </p:spPr>
+        <p:txBody>
+          <a:bodyPr/>
+          <a:p/>
+        </p:txBody>
       </p:sp>
       <p:sp>
         <p:nvSpPr>
@@ -13558,6 +13966,10 @@
           </a:solidFill>
           <a:ln/>
         </p:spPr>
+        <p:txBody>
+          <a:bodyPr/>
+          <a:p/>
+        </p:txBody>
       </p:sp>
       <p:sp>
         <p:nvSpPr>
@@ -13663,6 +14075,10 @@
             <a:prstDash val="solid"/>
           </a:ln>
         </p:spPr>
+        <p:txBody>
+          <a:bodyPr/>
+          <a:p/>
+        </p:txBody>
       </p:sp>
       <p:sp>
         <p:nvSpPr>
@@ -13683,6 +14099,10 @@
           </a:solidFill>
           <a:ln/>
         </p:spPr>
+        <p:txBody>
+          <a:bodyPr/>
+          <a:p/>
+        </p:txBody>
       </p:sp>
       <p:sp>
         <p:nvSpPr>
@@ -13788,6 +14208,10 @@
             <a:prstDash val="solid"/>
           </a:ln>
         </p:spPr>
+        <p:txBody>
+          <a:bodyPr/>
+          <a:p/>
+        </p:txBody>
       </p:sp>
       <p:sp>
         <p:nvSpPr>
@@ -14003,6 +14427,10 @@
             <a:prstDash val="solid"/>
           </a:ln>
         </p:spPr>
+        <p:txBody>
+          <a:bodyPr/>
+          <a:p/>
+        </p:txBody>
       </p:sp>
       <p:sp>
         <p:nvSpPr>
@@ -14023,6 +14451,10 @@
           </a:solidFill>
           <a:ln/>
         </p:spPr>
+        <p:txBody>
+          <a:bodyPr/>
+          <a:p/>
+        </p:txBody>
       </p:sp>
       <p:sp>
         <p:nvSpPr>
@@ -14206,6 +14638,10 @@
             <a:prstDash val="solid"/>
           </a:ln>
         </p:spPr>
+        <p:txBody>
+          <a:bodyPr/>
+          <a:p/>
+        </p:txBody>
       </p:sp>
       <p:sp>
         <p:nvSpPr>
@@ -14226,6 +14662,10 @@
           </a:solidFill>
           <a:ln/>
         </p:spPr>
+        <p:txBody>
+          <a:bodyPr/>
+          <a:p/>
+        </p:txBody>
       </p:sp>
       <p:sp>
         <p:nvSpPr>
@@ -14409,6 +14849,10 @@
             <a:prstDash val="solid"/>
           </a:ln>
         </p:spPr>
+        <p:txBody>
+          <a:bodyPr/>
+          <a:p/>
+        </p:txBody>
       </p:sp>
       <p:sp>
         <p:nvSpPr>
@@ -14429,6 +14873,10 @@
           </a:solidFill>
           <a:ln/>
         </p:spPr>
+        <p:txBody>
+          <a:bodyPr/>
+          <a:p/>
+        </p:txBody>
       </p:sp>
       <p:sp>
         <p:nvSpPr>
@@ -14683,6 +15131,10 @@
             <a:prstDash val="solid"/>
           </a:ln>
         </p:spPr>
+        <p:txBody>
+          <a:bodyPr/>
+          <a:p/>
+        </p:txBody>
       </p:sp>
       <p:sp>
         <p:nvSpPr>
@@ -14827,6 +15279,10 @@
             <a:prstDash val="solid"/>
           </a:ln>
         </p:spPr>
+        <p:txBody>
+          <a:bodyPr/>
+          <a:p/>
+        </p:txBody>
       </p:sp>
       <p:sp>
         <p:nvSpPr>
@@ -14932,6 +15388,10 @@
             <a:prstDash val="solid"/>
           </a:ln>
         </p:spPr>
+        <p:txBody>
+          <a:bodyPr/>
+          <a:p/>
+        </p:txBody>
       </p:sp>
       <p:sp>
         <p:nvSpPr>
@@ -15037,6 +15497,10 @@
             <a:prstDash val="solid"/>
           </a:ln>
         </p:spPr>
+        <p:txBody>
+          <a:bodyPr/>
+          <a:p/>
+        </p:txBody>
       </p:sp>
       <p:sp>
         <p:nvSpPr>
@@ -15174,6 +15638,10 @@
             <a:prstDash val="solid"/>
           </a:ln>
         </p:spPr>
+        <p:txBody>
+          <a:bodyPr/>
+          <a:p/>
+        </p:txBody>
       </p:sp>
       <p:sp>
         <p:nvSpPr>
@@ -15318,6 +15786,10 @@
             <a:prstDash val="solid"/>
           </a:ln>
         </p:spPr>
+        <p:txBody>
+          <a:bodyPr/>
+          <a:p/>
+        </p:txBody>
       </p:sp>
       <p:sp>
         <p:nvSpPr>
@@ -15338,6 +15810,10 @@
           </a:solidFill>
           <a:ln/>
         </p:spPr>
+        <p:txBody>
+          <a:bodyPr/>
+          <a:p/>
+        </p:txBody>
       </p:sp>
       <p:sp>
         <p:nvSpPr>
@@ -15443,6 +15919,10 @@
             <a:prstDash val="solid"/>
           </a:ln>
         </p:spPr>
+        <p:txBody>
+          <a:bodyPr/>
+          <a:p/>
+        </p:txBody>
       </p:sp>
       <p:sp>
         <p:nvSpPr>
@@ -15463,6 +15943,10 @@
           </a:solidFill>
           <a:ln/>
         </p:spPr>
+        <p:txBody>
+          <a:bodyPr/>
+          <a:p/>
+        </p:txBody>
       </p:sp>
       <p:sp>
         <p:nvSpPr>
@@ -15568,6 +16052,10 @@
             <a:prstDash val="solid"/>
           </a:ln>
         </p:spPr>
+        <p:txBody>
+          <a:bodyPr/>
+          <a:p/>
+        </p:txBody>
       </p:sp>
       <p:sp>
         <p:nvSpPr>
@@ -15588,6 +16076,10 @@
           </a:solidFill>
           <a:ln/>
         </p:spPr>
+        <p:txBody>
+          <a:bodyPr/>
+          <a:p/>
+        </p:txBody>
       </p:sp>
       <p:sp>
         <p:nvSpPr>
@@ -15693,6 +16185,10 @@
             <a:prstDash val="solid"/>
           </a:ln>
         </p:spPr>
+        <p:txBody>
+          <a:bodyPr/>
+          <a:p/>
+        </p:txBody>
       </p:sp>
       <p:sp>
         <p:nvSpPr>
@@ -15713,6 +16209,10 @@
           </a:solidFill>
           <a:ln/>
         </p:spPr>
+        <p:txBody>
+          <a:bodyPr/>
+          <a:p/>
+        </p:txBody>
       </p:sp>
       <p:sp>
         <p:nvSpPr>
@@ -15818,6 +16318,10 @@
             <a:prstDash val="solid"/>
           </a:ln>
         </p:spPr>
+        <p:txBody>
+          <a:bodyPr/>
+          <a:p/>
+        </p:txBody>
       </p:sp>
       <p:sp>
         <p:nvSpPr>
@@ -16033,6 +16537,10 @@
             <a:prstDash val="solid"/>
           </a:ln>
         </p:spPr>
+        <p:txBody>
+          <a:bodyPr/>
+          <a:p/>
+        </p:txBody>
       </p:sp>
       <p:sp>
         <p:nvSpPr>
@@ -16058,6 +16566,10 @@
             <a:prstDash val="solid"/>
           </a:ln>
         </p:spPr>
+        <p:txBody>
+          <a:bodyPr/>
+          <a:p/>
+        </p:txBody>
       </p:sp>
       <p:sp>
         <p:nvSpPr>
@@ -16163,6 +16675,10 @@
             <a:prstDash val="solid"/>
           </a:ln>
         </p:spPr>
+        <p:txBody>
+          <a:bodyPr/>
+          <a:p/>
+        </p:txBody>
       </p:sp>
       <p:sp>
         <p:nvSpPr>
@@ -16188,6 +16704,10 @@
             <a:prstDash val="solid"/>
           </a:ln>
         </p:spPr>
+        <p:txBody>
+          <a:bodyPr/>
+          <a:p/>
+        </p:txBody>
       </p:sp>
       <p:sp>
         <p:nvSpPr>
@@ -16293,6 +16813,10 @@
             <a:prstDash val="solid"/>
           </a:ln>
         </p:spPr>
+        <p:txBody>
+          <a:bodyPr/>
+          <a:p/>
+        </p:txBody>
       </p:sp>
       <p:sp>
         <p:nvSpPr>
@@ -16469,6 +16993,10 @@
             <a:prstDash val="solid"/>
           </a:ln>
         </p:spPr>
+        <p:txBody>
+          <a:bodyPr/>
+          <a:p/>
+        </p:txBody>
       </p:sp>
       <p:sp>
         <p:nvSpPr>
@@ -16533,6 +17061,10 @@
             <a:prstDash val="solid"/>
           </a:ln>
         </p:spPr>
+        <p:txBody>
+          <a:bodyPr/>
+          <a:p/>
+        </p:txBody>
       </p:sp>
       <p:sp>
         <p:nvSpPr>
@@ -16558,6 +17090,10 @@
             <a:prstDash val="solid"/>
           </a:ln>
         </p:spPr>
+        <p:txBody>
+          <a:bodyPr/>
+          <a:p/>
+        </p:txBody>
       </p:sp>
       <p:sp>
         <p:nvSpPr>
@@ -16622,6 +17158,10 @@
             <a:prstDash val="solid"/>
           </a:ln>
         </p:spPr>
+        <p:txBody>
+          <a:bodyPr/>
+          <a:p/>
+        </p:txBody>
       </p:sp>
       <p:sp>
         <p:nvSpPr>
@@ -16686,6 +17226,10 @@
             <a:prstDash val="solid"/>
           </a:ln>
         </p:spPr>
+        <p:txBody>
+          <a:bodyPr/>
+          <a:p/>
+        </p:txBody>
       </p:sp>
       <p:sp>
         <p:nvSpPr>
@@ -16711,6 +17255,10 @@
             <a:prstDash val="solid"/>
           </a:ln>
         </p:spPr>
+        <p:txBody>
+          <a:bodyPr/>
+          <a:p/>
+        </p:txBody>
       </p:sp>
       <p:sp>
         <p:nvSpPr>
@@ -16775,6 +17323,10 @@
             <a:prstDash val="solid"/>
           </a:ln>
         </p:spPr>
+        <p:txBody>
+          <a:bodyPr/>
+          <a:p/>
+        </p:txBody>
       </p:sp>
       <p:sp>
         <p:nvSpPr>
@@ -17230,6 +17782,10 @@
             <a:prstDash val="solid"/>
           </a:ln>
         </p:spPr>
+        <p:txBody>
+          <a:bodyPr/>
+          <a:p/>
+        </p:txBody>
       </p:sp>
       <p:sp>
         <p:nvSpPr>
@@ -17413,6 +17969,10 @@
             <a:prstDash val="solid"/>
           </a:ln>
         </p:spPr>
+        <p:txBody>
+          <a:bodyPr/>
+          <a:p/>
+        </p:txBody>
       </p:sp>
       <p:sp>
         <p:nvSpPr>
@@ -17438,6 +17998,10 @@
             <a:prstDash val="solid"/>
           </a:ln>
         </p:spPr>
+        <p:txBody>
+          <a:bodyPr/>
+          <a:p/>
+        </p:txBody>
       </p:sp>
       <p:sp>
         <p:nvSpPr>
@@ -17543,6 +18107,10 @@
             <a:prstDash val="solid"/>
           </a:ln>
         </p:spPr>
+        <p:txBody>
+          <a:bodyPr/>
+          <a:p/>
+        </p:txBody>
       </p:sp>
       <p:sp>
         <p:nvSpPr>
@@ -17568,6 +18136,10 @@
             <a:prstDash val="solid"/>
           </a:ln>
         </p:spPr>
+        <p:txBody>
+          <a:bodyPr/>
+          <a:p/>
+        </p:txBody>
       </p:sp>
       <p:sp>
         <p:nvSpPr>
@@ -17673,6 +18245,10 @@
             <a:prstDash val="solid"/>
           </a:ln>
         </p:spPr>
+        <p:txBody>
+          <a:bodyPr/>
+          <a:p/>
+        </p:txBody>
       </p:sp>
       <p:sp>
         <p:nvSpPr>
@@ -17698,6 +18274,10 @@
             <a:prstDash val="solid"/>
           </a:ln>
         </p:spPr>
+        <p:txBody>
+          <a:bodyPr/>
+          <a:p/>
+        </p:txBody>
       </p:sp>
       <p:sp>
         <p:nvSpPr>
@@ -17803,6 +18383,10 @@
             <a:prstDash val="solid"/>
           </a:ln>
         </p:spPr>
+        <p:txBody>
+          <a:bodyPr/>
+          <a:p/>
+        </p:txBody>
       </p:sp>
       <p:sp>
         <p:nvSpPr>
@@ -17828,6 +18412,10 @@
             <a:prstDash val="solid"/>
           </a:ln>
         </p:spPr>
+        <p:txBody>
+          <a:bodyPr/>
+          <a:p/>
+        </p:txBody>
       </p:sp>
       <p:sp>
         <p:nvSpPr>
@@ -18158,6 +18746,10 @@
             <a:prstDash val="solid"/>
           </a:ln>
         </p:spPr>
+        <p:txBody>
+          <a:bodyPr/>
+          <a:p/>
+        </p:txBody>
       </p:sp>
       <p:sp>
         <p:nvSpPr>
@@ -18410,6 +19002,10 @@
             </a:outerShdw>
           </a:effectLst>
         </p:spPr>
+        <p:txBody>
+          <a:bodyPr/>
+          <a:p/>
+        </p:txBody>
       </p:sp>
       <p:sp>
         <p:nvSpPr>
@@ -18474,6 +19070,10 @@
             <a:prstDash val="solid"/>
           </a:ln>
         </p:spPr>
+        <p:txBody>
+          <a:bodyPr/>
+          <a:p/>
+        </p:txBody>
       </p:sp>
       <p:sp>
         <p:nvSpPr>
@@ -18499,6 +19099,10 @@
             <a:prstDash val="solid"/>
           </a:ln>
         </p:spPr>
+        <p:txBody>
+          <a:bodyPr/>
+          <a:p/>
+        </p:txBody>
       </p:sp>
       <p:sp>
         <p:nvSpPr>
@@ -18524,6 +19128,10 @@
             <a:prstDash val="solid"/>
           </a:ln>
         </p:spPr>
+        <p:txBody>
+          <a:bodyPr/>
+          <a:p/>
+        </p:txBody>
       </p:sp>
       <p:sp>
         <p:nvSpPr>
@@ -18549,6 +19157,10 @@
             <a:prstDash val="solid"/>
           </a:ln>
         </p:spPr>
+        <p:txBody>
+          <a:bodyPr/>
+          <a:p/>
+        </p:txBody>
       </p:sp>
       <p:sp>
         <p:nvSpPr>
@@ -18574,6 +19186,10 @@
             <a:prstDash val="solid"/>
           </a:ln>
         </p:spPr>
+        <p:txBody>
+          <a:bodyPr/>
+          <a:p/>
+        </p:txBody>
       </p:sp>
       <p:sp>
         <p:nvSpPr>
@@ -18599,6 +19215,10 @@
             <a:prstDash val="solid"/>
           </a:ln>
         </p:spPr>
+        <p:txBody>
+          <a:bodyPr/>
+          <a:p/>
+        </p:txBody>
       </p:sp>
       <p:sp>
         <p:nvSpPr>
@@ -18624,6 +19244,10 @@
             <a:prstDash val="solid"/>
           </a:ln>
         </p:spPr>
+        <p:txBody>
+          <a:bodyPr/>
+          <a:p/>
+        </p:txBody>
       </p:sp>
       <p:sp>
         <p:nvSpPr>
@@ -18649,6 +19273,10 @@
             <a:prstDash val="solid"/>
           </a:ln>
         </p:spPr>
+        <p:txBody>
+          <a:bodyPr/>
+          <a:p/>
+        </p:txBody>
       </p:sp>
       <p:sp>
         <p:nvSpPr>
@@ -18674,6 +19302,10 @@
             <a:prstDash val="solid"/>
           </a:ln>
         </p:spPr>
+        <p:txBody>
+          <a:bodyPr/>
+          <a:p/>
+        </p:txBody>
       </p:sp>
       <p:sp>
         <p:nvSpPr>
@@ -18699,6 +19331,10 @@
             <a:prstDash val="solid"/>
           </a:ln>
         </p:spPr>
+        <p:txBody>
+          <a:bodyPr/>
+          <a:p/>
+        </p:txBody>
       </p:sp>
       <p:sp>
         <p:nvSpPr>
@@ -18724,6 +19360,10 @@
             <a:prstDash val="solid"/>
           </a:ln>
         </p:spPr>
+        <p:txBody>
+          <a:bodyPr/>
+          <a:p/>
+        </p:txBody>
       </p:sp>
       <p:sp>
         <p:nvSpPr>
@@ -18749,6 +19389,10 @@
             <a:prstDash val="solid"/>
           </a:ln>
         </p:spPr>
+        <p:txBody>
+          <a:bodyPr/>
+          <a:p/>
+        </p:txBody>
       </p:sp>
       <p:sp>
         <p:nvSpPr>
@@ -18774,6 +19418,10 @@
             <a:prstDash val="solid"/>
           </a:ln>
         </p:spPr>
+        <p:txBody>
+          <a:bodyPr/>
+          <a:p/>
+        </p:txBody>
       </p:sp>
       <p:sp>
         <p:nvSpPr>
@@ -18799,6 +19447,10 @@
             <a:prstDash val="solid"/>
           </a:ln>
         </p:spPr>
+        <p:txBody>
+          <a:bodyPr/>
+          <a:p/>
+        </p:txBody>
       </p:sp>
       <p:sp>
         <p:nvSpPr>
@@ -18824,6 +19476,10 @@
             <a:prstDash val="solid"/>
           </a:ln>
         </p:spPr>
+        <p:txBody>
+          <a:bodyPr/>
+          <a:p/>
+        </p:txBody>
       </p:sp>
       <p:sp>
         <p:nvSpPr>
@@ -18849,6 +19505,10 @@
             <a:prstDash val="solid"/>
           </a:ln>
         </p:spPr>
+        <p:txBody>
+          <a:bodyPr/>
+          <a:p/>
+        </p:txBody>
       </p:sp>
       <p:sp>
         <p:nvSpPr>
@@ -18874,6 +19534,10 @@
             <a:prstDash val="solid"/>
           </a:ln>
         </p:spPr>
+        <p:txBody>
+          <a:bodyPr/>
+          <a:p/>
+        </p:txBody>
       </p:sp>
       <p:sp>
         <p:nvSpPr>
@@ -18899,6 +19563,10 @@
             <a:prstDash val="solid"/>
           </a:ln>
         </p:spPr>
+        <p:txBody>
+          <a:bodyPr/>
+          <a:p/>
+        </p:txBody>
       </p:sp>
       <p:sp>
         <p:nvSpPr>
@@ -18924,6 +19592,10 @@
             <a:prstDash val="solid"/>
           </a:ln>
         </p:spPr>
+        <p:txBody>
+          <a:bodyPr/>
+          <a:p/>
+        </p:txBody>
       </p:sp>
       <p:sp>
         <p:nvSpPr>
@@ -18949,6 +19621,10 @@
             <a:prstDash val="solid"/>
           </a:ln>
         </p:spPr>
+        <p:txBody>
+          <a:bodyPr/>
+          <a:p/>
+        </p:txBody>
       </p:sp>
       <p:sp>
         <p:nvSpPr>
@@ -18974,6 +19650,10 @@
             <a:prstDash val="solid"/>
           </a:ln>
         </p:spPr>
+        <p:txBody>
+          <a:bodyPr/>
+          <a:p/>
+        </p:txBody>
       </p:sp>
       <p:sp>
         <p:nvSpPr>
@@ -18999,6 +19679,10 @@
             <a:prstDash val="solid"/>
           </a:ln>
         </p:spPr>
+        <p:txBody>
+          <a:bodyPr/>
+          <a:p/>
+        </p:txBody>
       </p:sp>
       <p:sp>
         <p:nvSpPr>
@@ -19024,6 +19708,10 @@
             <a:prstDash val="solid"/>
           </a:ln>
         </p:spPr>
+        <p:txBody>
+          <a:bodyPr/>
+          <a:p/>
+        </p:txBody>
       </p:sp>
       <p:sp>
         <p:nvSpPr>
@@ -19049,6 +19737,10 @@
             <a:prstDash val="solid"/>
           </a:ln>
         </p:spPr>
+        <p:txBody>
+          <a:bodyPr/>
+          <a:p/>
+        </p:txBody>
       </p:sp>
       <p:sp>
         <p:nvSpPr>
@@ -19074,6 +19766,10 @@
             <a:prstDash val="solid"/>
           </a:ln>
         </p:spPr>
+        <p:txBody>
+          <a:bodyPr/>
+          <a:p/>
+        </p:txBody>
       </p:sp>
       <p:sp>
         <p:nvSpPr>
@@ -19328,6 +20024,10 @@
             <a:prstDash val="solid"/>
           </a:ln>
         </p:spPr>
+        <p:txBody>
+          <a:bodyPr/>
+          <a:p/>
+        </p:txBody>
       </p:sp>
       <p:sp>
         <p:nvSpPr>
@@ -19472,6 +20172,10 @@
             <a:prstDash val="solid"/>
           </a:ln>
         </p:spPr>
+        <p:txBody>
+          <a:bodyPr/>
+          <a:p/>
+        </p:txBody>
       </p:sp>
       <p:sp>
         <p:nvSpPr>
@@ -19802,6 +20506,10 @@
             <a:prstDash val="solid"/>
           </a:ln>
         </p:spPr>
+        <p:txBody>
+          <a:bodyPr/>
+          <a:p/>
+        </p:txBody>
       </p:sp>
       <p:sp>
         <p:nvSpPr>
@@ -19905,6 +20613,10 @@
             <a:prstDash val="solid"/>
           </a:ln>
         </p:spPr>
+        <p:txBody>
+          <a:bodyPr/>
+          <a:p/>
+        </p:txBody>
       </p:sp>
       <p:sp>
         <p:nvSpPr>
@@ -20047,6 +20759,10 @@
             <a:prstDash val="solid"/>
           </a:ln>
         </p:spPr>
+        <p:txBody>
+          <a:bodyPr/>
+          <a:p/>
+        </p:txBody>
       </p:sp>
       <p:sp>
         <p:nvSpPr>
@@ -20150,6 +20866,10 @@
             <a:prstDash val="solid"/>
           </a:ln>
         </p:spPr>
+        <p:txBody>
+          <a:bodyPr/>
+          <a:p/>
+        </p:txBody>
       </p:sp>
       <p:sp>
         <p:nvSpPr>
@@ -20216,6 +20936,10 @@
             <a:prstDash val="solid"/>
           </a:ln>
         </p:spPr>
+        <p:txBody>
+          <a:bodyPr/>
+          <a:p/>
+        </p:txBody>
       </p:sp>
       <p:sp>
         <p:nvSpPr>
@@ -20353,6 +21077,10 @@
             <a:prstDash val="solid"/>
           </a:ln>
         </p:spPr>
+        <p:txBody>
+          <a:bodyPr/>
+          <a:p/>
+        </p:txBody>
       </p:sp>
       <p:sp>
         <p:nvSpPr>
@@ -20419,6 +21147,10 @@
             <a:prstDash val="solid"/>
           </a:ln>
         </p:spPr>
+        <p:txBody>
+          <a:bodyPr/>
+          <a:p/>
+        </p:txBody>
       </p:sp>
       <p:sp>
         <p:nvSpPr>
@@ -20563,6 +21295,10 @@
             <a:prstDash val="solid"/>
           </a:ln>
         </p:spPr>
+        <p:txBody>
+          <a:bodyPr/>
+          <a:p/>
+        </p:txBody>
       </p:sp>
       <p:sp>
         <p:nvSpPr>
@@ -20588,6 +21324,10 @@
             <a:prstDash val="solid"/>
           </a:ln>
         </p:spPr>
+        <p:txBody>
+          <a:bodyPr/>
+          <a:p/>
+        </p:txBody>
       </p:sp>
       <p:sp>
         <p:nvSpPr>
@@ -20652,6 +21392,10 @@
             <a:prstDash val="solid"/>
           </a:ln>
         </p:spPr>
+        <p:txBody>
+          <a:bodyPr/>
+          <a:p/>
+        </p:txBody>
       </p:sp>
       <p:sp>
         <p:nvSpPr>
@@ -20679,6 +21423,10 @@
             <a:prstDash val="solid"/>
           </a:ln>
         </p:spPr>
+        <p:txBody>
+          <a:bodyPr/>
+          <a:p/>
+        </p:txBody>
       </p:sp>
       <p:sp>
         <p:nvSpPr>
@@ -20704,6 +21452,10 @@
             <a:prstDash val="solid"/>
           </a:ln>
         </p:spPr>
+        <p:txBody>
+          <a:bodyPr/>
+          <a:p/>
+        </p:txBody>
       </p:sp>
       <p:sp>
         <p:nvSpPr>
@@ -20729,6 +21481,10 @@
             <a:prstDash val="solid"/>
           </a:ln>
         </p:spPr>
+        <p:txBody>
+          <a:bodyPr/>
+          <a:p/>
+        </p:txBody>
       </p:sp>
       <p:sp>
         <p:nvSpPr>
@@ -20754,6 +21510,10 @@
             <a:prstDash val="solid"/>
           </a:ln>
         </p:spPr>
+        <p:txBody>
+          <a:bodyPr/>
+          <a:p/>
+        </p:txBody>
       </p:sp>
       <p:sp>
         <p:nvSpPr>
@@ -20779,6 +21539,10 @@
             <a:prstDash val="solid"/>
           </a:ln>
         </p:spPr>
+        <p:txBody>
+          <a:bodyPr/>
+          <a:p/>
+        </p:txBody>
       </p:sp>
       <p:sp>
         <p:nvSpPr>
@@ -20804,6 +21568,10 @@
             <a:prstDash val="solid"/>
           </a:ln>
         </p:spPr>
+        <p:txBody>
+          <a:bodyPr/>
+          <a:p/>
+        </p:txBody>
       </p:sp>
       <p:sp>
         <p:nvSpPr>
@@ -20829,6 +21597,10 @@
             <a:prstDash val="solid"/>
           </a:ln>
         </p:spPr>
+        <p:txBody>
+          <a:bodyPr/>
+          <a:p/>
+        </p:txBody>
       </p:sp>
       <p:sp>
         <p:nvSpPr>
@@ -20854,6 +21626,10 @@
             <a:prstDash val="solid"/>
           </a:ln>
         </p:spPr>
+        <p:txBody>
+          <a:bodyPr/>
+          <a:p/>
+        </p:txBody>
       </p:sp>
       <p:sp>
         <p:nvSpPr>
@@ -20879,6 +21655,10 @@
             <a:prstDash val="solid"/>
           </a:ln>
         </p:spPr>
+        <p:txBody>
+          <a:bodyPr/>
+          <a:p/>
+        </p:txBody>
       </p:sp>
       <p:sp>
         <p:nvSpPr>
@@ -20904,6 +21684,10 @@
             <a:prstDash val="solid"/>
           </a:ln>
         </p:spPr>
+        <p:txBody>
+          <a:bodyPr/>
+          <a:p/>
+        </p:txBody>
       </p:sp>
       <p:sp>
         <p:nvSpPr>
@@ -20929,6 +21713,10 @@
             <a:prstDash val="solid"/>
           </a:ln>
         </p:spPr>
+        <p:txBody>
+          <a:bodyPr/>
+          <a:p/>
+        </p:txBody>
       </p:sp>
       <p:sp>
         <p:nvSpPr>
@@ -20954,6 +21742,10 @@
             <a:prstDash val="solid"/>
           </a:ln>
         </p:spPr>
+        <p:txBody>
+          <a:bodyPr/>
+          <a:p/>
+        </p:txBody>
       </p:sp>
       <p:sp>
         <p:nvSpPr>
@@ -20979,6 +21771,10 @@
             <a:prstDash val="solid"/>
           </a:ln>
         </p:spPr>
+        <p:txBody>
+          <a:bodyPr/>
+          <a:p/>
+        </p:txBody>
       </p:sp>
       <p:sp>
         <p:nvSpPr>
@@ -21004,6 +21800,10 @@
             <a:prstDash val="solid"/>
           </a:ln>
         </p:spPr>
+        <p:txBody>
+          <a:bodyPr/>
+          <a:p/>
+        </p:txBody>
       </p:sp>
       <p:sp>
         <p:nvSpPr>
@@ -21029,6 +21829,10 @@
             <a:prstDash val="solid"/>
           </a:ln>
         </p:spPr>
+        <p:txBody>
+          <a:bodyPr/>
+          <a:p/>
+        </p:txBody>
       </p:sp>
       <p:sp>
         <p:nvSpPr>
@@ -21054,6 +21858,10 @@
             <a:prstDash val="solid"/>
           </a:ln>
         </p:spPr>
+        <p:txBody>
+          <a:bodyPr/>
+          <a:p/>
+        </p:txBody>
       </p:sp>
       <p:sp>
         <p:nvSpPr>
@@ -21079,6 +21887,10 @@
             <a:prstDash val="solid"/>
           </a:ln>
         </p:spPr>
+        <p:txBody>
+          <a:bodyPr/>
+          <a:p/>
+        </p:txBody>
       </p:sp>
       <p:sp>
         <p:nvSpPr>
@@ -21104,6 +21916,10 @@
             <a:prstDash val="solid"/>
           </a:ln>
         </p:spPr>
+        <p:txBody>
+          <a:bodyPr/>
+          <a:p/>
+        </p:txBody>
       </p:sp>
       <p:sp>
         <p:nvSpPr>
@@ -21129,6 +21945,10 @@
             <a:prstDash val="solid"/>
           </a:ln>
         </p:spPr>
+        <p:txBody>
+          <a:bodyPr/>
+          <a:p/>
+        </p:txBody>
       </p:sp>
       <p:sp>
         <p:nvSpPr>
@@ -21154,6 +21974,10 @@
             <a:prstDash val="solid"/>
           </a:ln>
         </p:spPr>
+        <p:txBody>
+          <a:bodyPr/>
+          <a:p/>
+        </p:txBody>
       </p:sp>
       <p:sp>
         <p:nvSpPr>
@@ -21179,6 +22003,10 @@
             <a:prstDash val="solid"/>
           </a:ln>
         </p:spPr>
+        <p:txBody>
+          <a:bodyPr/>
+          <a:p/>
+        </p:txBody>
       </p:sp>
       <p:sp>
         <p:nvSpPr>
@@ -21204,6 +22032,10 @@
             <a:prstDash val="solid"/>
           </a:ln>
         </p:spPr>
+        <p:txBody>
+          <a:bodyPr/>
+          <a:p/>
+        </p:txBody>
       </p:sp>
       <p:sp>
         <p:nvSpPr>
@@ -21229,6 +22061,10 @@
             <a:prstDash val="solid"/>
           </a:ln>
         </p:spPr>
+        <p:txBody>
+          <a:bodyPr/>
+          <a:p/>
+        </p:txBody>
       </p:sp>
       <p:sp>
         <p:nvSpPr>
@@ -21254,6 +22090,10 @@
             <a:prstDash val="solid"/>
           </a:ln>
         </p:spPr>
+        <p:txBody>
+          <a:bodyPr/>
+          <a:p/>
+        </p:txBody>
       </p:sp>
       <p:sp>
         <p:nvSpPr>
@@ -21279,6 +22119,10 @@
             <a:prstDash val="solid"/>
           </a:ln>
         </p:spPr>
+        <p:txBody>
+          <a:bodyPr/>
+          <a:p/>
+        </p:txBody>
       </p:sp>
       <p:sp>
         <p:nvSpPr>
@@ -21304,6 +22148,10 @@
             <a:prstDash val="solid"/>
           </a:ln>
         </p:spPr>
+        <p:txBody>
+          <a:bodyPr/>
+          <a:p/>
+        </p:txBody>
       </p:sp>
       <p:sp>
         <p:nvSpPr>
@@ -21329,6 +22177,10 @@
             <a:prstDash val="solid"/>
           </a:ln>
         </p:spPr>
+        <p:txBody>
+          <a:bodyPr/>
+          <a:p/>
+        </p:txBody>
       </p:sp>
       <p:sp>
         <p:nvSpPr>
@@ -21354,6 +22206,10 @@
             <a:prstDash val="solid"/>
           </a:ln>
         </p:spPr>
+        <p:txBody>
+          <a:bodyPr/>
+          <a:p/>
+        </p:txBody>
       </p:sp>
       <p:sp>
         <p:nvSpPr>
@@ -21379,6 +22235,10 @@
             <a:prstDash val="solid"/>
           </a:ln>
         </p:spPr>
+        <p:txBody>
+          <a:bodyPr/>
+          <a:p/>
+        </p:txBody>
       </p:sp>
       <p:sp>
         <p:nvSpPr>
@@ -21404,6 +22264,10 @@
             <a:prstDash val="solid"/>
           </a:ln>
         </p:spPr>
+        <p:txBody>
+          <a:bodyPr/>
+          <a:p/>
+        </p:txBody>
       </p:sp>
       <p:sp>
         <p:nvSpPr>
@@ -21429,6 +22293,10 @@
             <a:prstDash val="solid"/>
           </a:ln>
         </p:spPr>
+        <p:txBody>
+          <a:bodyPr/>
+          <a:p/>
+        </p:txBody>
       </p:sp>
       <p:sp>
         <p:nvSpPr>
@@ -21454,6 +22322,10 @@
             <a:prstDash val="solid"/>
           </a:ln>
         </p:spPr>
+        <p:txBody>
+          <a:bodyPr/>
+          <a:p/>
+        </p:txBody>
       </p:sp>
       <p:sp>
         <p:nvSpPr>
@@ -21479,6 +22351,10 @@
             <a:prstDash val="solid"/>
           </a:ln>
         </p:spPr>
+        <p:txBody>
+          <a:bodyPr/>
+          <a:p/>
+        </p:txBody>
       </p:sp>
       <p:sp>
         <p:nvSpPr>
@@ -21504,6 +22380,10 @@
             <a:prstDash val="solid"/>
           </a:ln>
         </p:spPr>
+        <p:txBody>
+          <a:bodyPr/>
+          <a:p/>
+        </p:txBody>
       </p:sp>
       <p:sp>
         <p:nvSpPr>
@@ -21529,6 +22409,10 @@
             <a:prstDash val="solid"/>
           </a:ln>
         </p:spPr>
+        <p:txBody>
+          <a:bodyPr/>
+          <a:p/>
+        </p:txBody>
       </p:sp>
       <p:sp>
         <p:nvSpPr>
@@ -21554,6 +22438,10 @@
             <a:prstDash val="solid"/>
           </a:ln>
         </p:spPr>
+        <p:txBody>
+          <a:bodyPr/>
+          <a:p/>
+        </p:txBody>
       </p:sp>
       <p:sp>
         <p:nvSpPr>
@@ -21579,6 +22467,10 @@
             <a:prstDash val="solid"/>
           </a:ln>
         </p:spPr>
+        <p:txBody>
+          <a:bodyPr/>
+          <a:p/>
+        </p:txBody>
       </p:sp>
       <p:sp>
         <p:nvSpPr>
@@ -21755,6 +22647,10 @@
             <a:prstDash val="solid"/>
           </a:ln>
         </p:spPr>
+        <p:txBody>
+          <a:bodyPr/>
+          <a:p/>
+        </p:txBody>
       </p:sp>
       <p:sp>
         <p:nvSpPr>
@@ -21899,6 +22795,10 @@
             <a:prstDash val="solid"/>
           </a:ln>
         </p:spPr>
+        <p:txBody>
+          <a:bodyPr/>
+          <a:p/>
+        </p:txBody>
       </p:sp>
       <p:sp>
         <p:nvSpPr>
@@ -21924,6 +22824,10 @@
             <a:prstDash val="solid"/>
           </a:ln>
         </p:spPr>
+        <p:txBody>
+          <a:bodyPr/>
+          <a:p/>
+        </p:txBody>
       </p:sp>
       <p:sp>
         <p:nvSpPr>
@@ -22029,6 +22933,10 @@
             <a:prstDash val="solid"/>
           </a:ln>
         </p:spPr>
+        <p:txBody>
+          <a:bodyPr/>
+          <a:p/>
+        </p:txBody>
       </p:sp>
       <p:sp>
         <p:nvSpPr>
@@ -22054,6 +22962,10 @@
             <a:prstDash val="solid"/>
           </a:ln>
         </p:spPr>
+        <p:txBody>
+          <a:bodyPr/>
+          <a:p/>
+        </p:txBody>
       </p:sp>
       <p:sp>
         <p:nvSpPr>
@@ -22159,6 +23071,10 @@
             <a:prstDash val="solid"/>
           </a:ln>
         </p:spPr>
+        <p:txBody>
+          <a:bodyPr/>
+          <a:p/>
+        </p:txBody>
       </p:sp>
       <p:sp>
         <p:nvSpPr>
@@ -22184,6 +23100,10 @@
             <a:prstDash val="solid"/>
           </a:ln>
         </p:spPr>
+        <p:txBody>
+          <a:bodyPr/>
+          <a:p/>
+        </p:txBody>
       </p:sp>
       <p:sp>
         <p:nvSpPr>
@@ -22289,6 +23209,10 @@
             <a:prstDash val="solid"/>
           </a:ln>
         </p:spPr>
+        <p:txBody>
+          <a:bodyPr/>
+          <a:p/>
+        </p:txBody>
       </p:sp>
       <p:sp>
         <p:nvSpPr>
@@ -22314,6 +23238,10 @@
             <a:prstDash val="solid"/>
           </a:ln>
         </p:spPr>
+        <p:txBody>
+          <a:bodyPr/>
+          <a:p/>
+        </p:txBody>
       </p:sp>
       <p:sp>
         <p:nvSpPr>
@@ -22419,6 +23347,10 @@
             <a:prstDash val="solid"/>
           </a:ln>
         </p:spPr>
+        <p:txBody>
+          <a:bodyPr/>
+          <a:p/>
+        </p:txBody>
       </p:sp>
       <p:sp>
         <p:nvSpPr>
@@ -22595,6 +23527,10 @@
             <a:prstDash val="solid"/>
           </a:ln>
         </p:spPr>
+        <p:txBody>
+          <a:bodyPr/>
+          <a:p/>
+        </p:txBody>
       </p:sp>
       <p:sp>
         <p:nvSpPr>
@@ -22700,6 +23636,10 @@
             <a:prstDash val="solid"/>
           </a:ln>
         </p:spPr>
+        <p:txBody>
+          <a:bodyPr/>
+          <a:p/>
+        </p:txBody>
       </p:sp>
       <p:sp>
         <p:nvSpPr>
@@ -22805,6 +23745,10 @@
             <a:prstDash val="solid"/>
           </a:ln>
         </p:spPr>
+        <p:txBody>
+          <a:bodyPr/>
+          <a:p/>
+        </p:txBody>
       </p:sp>
       <p:sp>
         <p:nvSpPr>
@@ -22910,6 +23854,10 @@
             <a:prstDash val="solid"/>
           </a:ln>
         </p:spPr>
+        <p:txBody>
+          <a:bodyPr/>
+          <a:p/>
+        </p:txBody>
       </p:sp>
       <p:sp>
         <p:nvSpPr>
@@ -23125,6 +24073,10 @@
             <a:prstDash val="solid"/>
           </a:ln>
         </p:spPr>
+        <p:txBody>
+          <a:bodyPr/>
+          <a:p/>
+        </p:txBody>
       </p:sp>
       <p:sp>
         <p:nvSpPr>
@@ -23269,6 +24221,10 @@
             <a:prstDash val="solid"/>
           </a:ln>
         </p:spPr>
+        <p:txBody>
+          <a:bodyPr/>
+          <a:p/>
+        </p:txBody>
       </p:sp>
       <p:sp>
         <p:nvSpPr>
@@ -23294,6 +24250,10 @@
             <a:prstDash val="solid"/>
           </a:ln>
         </p:spPr>
+        <p:txBody>
+          <a:bodyPr/>
+          <a:p/>
+        </p:txBody>
       </p:sp>
       <p:sp>
         <p:nvSpPr>
@@ -23399,6 +24359,10 @@
             <a:prstDash val="solid"/>
           </a:ln>
         </p:spPr>
+        <p:txBody>
+          <a:bodyPr/>
+          <a:p/>
+        </p:txBody>
       </p:sp>
       <p:sp>
         <p:nvSpPr>
@@ -23424,6 +24388,10 @@
             <a:prstDash val="solid"/>
           </a:ln>
         </p:spPr>
+        <p:txBody>
+          <a:bodyPr/>
+          <a:p/>
+        </p:txBody>
       </p:sp>
       <p:sp>
         <p:nvSpPr>
@@ -23529,6 +24497,10 @@
             <a:prstDash val="solid"/>
           </a:ln>
         </p:spPr>
+        <p:txBody>
+          <a:bodyPr/>
+          <a:p/>
+        </p:txBody>
       </p:sp>
       <p:sp>
         <p:nvSpPr>
@@ -23554,6 +24526,10 @@
             <a:prstDash val="solid"/>
           </a:ln>
         </p:spPr>
+        <p:txBody>
+          <a:bodyPr/>
+          <a:p/>
+        </p:txBody>
       </p:sp>
       <p:sp>
         <p:nvSpPr>
@@ -23659,6 +24635,10 @@
             <a:prstDash val="solid"/>
           </a:ln>
         </p:spPr>
+        <p:txBody>
+          <a:bodyPr/>
+          <a:p/>
+        </p:txBody>
       </p:sp>
       <p:sp>
         <p:nvSpPr>
@@ -23684,6 +24664,10 @@
             <a:prstDash val="solid"/>
           </a:ln>
         </p:spPr>
+        <p:txBody>
+          <a:bodyPr/>
+          <a:p/>
+        </p:txBody>
       </p:sp>
       <p:sp>
         <p:nvSpPr>
@@ -23789,6 +24773,10 @@
             <a:prstDash val="solid"/>
           </a:ln>
         </p:spPr>
+        <p:txBody>
+          <a:bodyPr/>
+          <a:p/>
+        </p:txBody>
       </p:sp>
       <p:sp>
         <p:nvSpPr>
@@ -23887,6 +24875,10 @@
             <a:prstDash val="solid"/>
           </a:ln>
         </p:spPr>
+        <p:txBody>
+          <a:bodyPr/>
+          <a:p/>
+        </p:txBody>
       </p:sp>
       <p:sp>
         <p:nvSpPr>
@@ -24031,6 +25023,10 @@
             <a:prstDash val="solid"/>
           </a:ln>
         </p:spPr>
+        <p:txBody>
+          <a:bodyPr/>
+          <a:p/>
+        </p:txBody>
       </p:sp>
       <p:sp>
         <p:nvSpPr>
@@ -24051,6 +25047,10 @@
           </a:solidFill>
           <a:ln/>
         </p:spPr>
+        <p:txBody>
+          <a:bodyPr/>
+          <a:p/>
+        </p:txBody>
       </p:sp>
       <p:sp>
         <p:nvSpPr>
@@ -24195,6 +25195,10 @@
             <a:prstDash val="solid"/>
           </a:ln>
         </p:spPr>
+        <p:txBody>
+          <a:bodyPr/>
+          <a:p/>
+        </p:txBody>
       </p:sp>
       <p:sp>
         <p:nvSpPr>
@@ -24215,6 +25219,10 @@
           </a:solidFill>
           <a:ln/>
         </p:spPr>
+        <p:txBody>
+          <a:bodyPr/>
+          <a:p/>
+        </p:txBody>
       </p:sp>
       <p:sp>
         <p:nvSpPr>
@@ -24359,6 +25367,10 @@
             <a:prstDash val="solid"/>
           </a:ln>
         </p:spPr>
+        <p:txBody>
+          <a:bodyPr/>
+          <a:p/>
+        </p:txBody>
       </p:sp>
       <p:sp>
         <p:nvSpPr>
@@ -24379,6 +25391,10 @@
           </a:solidFill>
           <a:ln/>
         </p:spPr>
+        <p:txBody>
+          <a:bodyPr/>
+          <a:p/>
+        </p:txBody>
       </p:sp>
       <p:sp>
         <p:nvSpPr>
@@ -24523,6 +25539,10 @@
             <a:prstDash val="solid"/>
           </a:ln>
         </p:spPr>
+        <p:txBody>
+          <a:bodyPr/>
+          <a:p/>
+        </p:txBody>
       </p:sp>
       <p:sp>
         <p:nvSpPr>
@@ -24543,6 +25563,10 @@
           </a:solidFill>
           <a:ln/>
         </p:spPr>
+        <p:txBody>
+          <a:bodyPr/>
+          <a:p/>
+        </p:txBody>
       </p:sp>
       <p:sp>
         <p:nvSpPr>
@@ -24687,6 +25711,10 @@
             <a:prstDash val="solid"/>
           </a:ln>
         </p:spPr>
+        <p:txBody>
+          <a:bodyPr/>
+          <a:p/>
+        </p:txBody>
       </p:sp>
       <p:sp>
         <p:nvSpPr>
@@ -24863,6 +25891,10 @@
             <a:prstDash val="solid"/>
           </a:ln>
         </p:spPr>
+        <p:txBody>
+          <a:bodyPr/>
+          <a:p/>
+        </p:txBody>
       </p:sp>
       <p:sp>
         <p:nvSpPr>
@@ -24927,6 +25959,10 @@
             <a:prstDash val="solid"/>
           </a:ln>
         </p:spPr>
+        <p:txBody>
+          <a:bodyPr/>
+          <a:p/>
+        </p:txBody>
       </p:sp>
       <p:sp>
         <p:nvSpPr>
@@ -24993,6 +26029,10 @@
             <a:prstDash val="solid"/>
           </a:ln>
         </p:spPr>
+        <p:txBody>
+          <a:bodyPr/>
+          <a:p/>
+        </p:txBody>
       </p:sp>
       <p:sp>
         <p:nvSpPr>
@@ -25096,6 +26136,10 @@
             <a:prstDash val="solid"/>
           </a:ln>
         </p:spPr>
+        <p:txBody>
+          <a:bodyPr/>
+          <a:p/>
+        </p:txBody>
       </p:sp>
       <p:sp>
         <p:nvSpPr>
@@ -25162,6 +26206,10 @@
             <a:prstDash val="solid"/>
           </a:ln>
         </p:spPr>
+        <p:txBody>
+          <a:bodyPr/>
+          <a:p/>
+        </p:txBody>
       </p:sp>
       <p:sp>
         <p:nvSpPr>
@@ -25265,6 +26313,10 @@
             <a:prstDash val="solid"/>
           </a:ln>
         </p:spPr>
+        <p:txBody>
+          <a:bodyPr/>
+          <a:p/>
+        </p:txBody>
       </p:sp>
       <p:sp>
         <p:nvSpPr>
@@ -25331,6 +26383,10 @@
             <a:prstDash val="solid"/>
           </a:ln>
         </p:spPr>
+        <p:txBody>
+          <a:bodyPr/>
+          <a:p/>
+        </p:txBody>
       </p:sp>
       <p:sp>
         <p:nvSpPr>
@@ -25436,6 +26492,10 @@
             <a:prstDash val="solid"/>
           </a:ln>
         </p:spPr>
+        <p:txBody>
+          <a:bodyPr/>
+          <a:p/>
+        </p:txBody>
       </p:sp>
       <p:sp>
         <p:nvSpPr>
@@ -25573,6 +26633,10 @@
             <a:prstDash val="solid"/>
           </a:ln>
         </p:spPr>
+        <p:txBody>
+          <a:bodyPr/>
+          <a:p/>
+        </p:txBody>
       </p:sp>
       <p:sp>
         <p:nvSpPr>
@@ -25683,6 +26747,10 @@
             </a:outerShdw>
           </a:effectLst>
         </p:spPr>
+        <p:txBody>
+          <a:bodyPr/>
+          <a:p/>
+        </p:txBody>
       </p:sp>
       <p:sp>
         <p:nvSpPr>
@@ -25747,6 +26815,10 @@
             <a:prstDash val="solid"/>
           </a:ln>
         </p:spPr>
+        <p:txBody>
+          <a:bodyPr/>
+          <a:p/>
+        </p:txBody>
       </p:sp>
       <p:sp>
         <p:nvSpPr>
@@ -25811,6 +26883,10 @@
             <a:prstDash val="solid"/>
           </a:ln>
         </p:spPr>
+        <p:txBody>
+          <a:bodyPr/>
+          <a:p/>
+        </p:txBody>
       </p:sp>
       <p:sp>
         <p:nvSpPr>
@@ -25836,6 +26912,10 @@
             <a:prstDash val="solid"/>
           </a:ln>
         </p:spPr>
+        <p:txBody>
+          <a:bodyPr/>
+          <a:p/>
+        </p:txBody>
       </p:sp>
       <p:sp>
         <p:nvSpPr>
@@ -25861,6 +26941,10 @@
             <a:prstDash val="solid"/>
           </a:ln>
         </p:spPr>
+        <p:txBody>
+          <a:bodyPr/>
+          <a:p/>
+        </p:txBody>
       </p:sp>
       <p:sp>
         <p:nvSpPr>
@@ -25998,6 +27082,10 @@
             <a:prstDash val="solid"/>
           </a:ln>
         </p:spPr>
+        <p:txBody>
+          <a:bodyPr/>
+          <a:p/>
+        </p:txBody>
       </p:sp>
       <p:sp>
         <p:nvSpPr>
@@ -26101,6 +27189,10 @@
             <a:prstDash val="solid"/>
           </a:ln>
         </p:spPr>
+        <p:txBody>
+          <a:bodyPr/>
+          <a:p/>
+        </p:txBody>
       </p:sp>
       <p:sp>
         <p:nvSpPr>
@@ -26126,6 +27218,10 @@
             <a:prstDash val="solid"/>
           </a:ln>
         </p:spPr>
+        <p:txBody>
+          <a:bodyPr/>
+          <a:p/>
+        </p:txBody>
       </p:sp>
       <p:sp>
         <p:nvSpPr>
@@ -26536,6 +27632,10 @@
             <a:prstDash val="solid"/>
           </a:ln>
         </p:spPr>
+        <p:txBody>
+          <a:bodyPr/>
+          <a:p/>
+        </p:txBody>
       </p:sp>
       <p:sp>
         <p:nvSpPr>
@@ -26561,6 +27661,10 @@
             <a:prstDash val="solid"/>
           </a:ln>
         </p:spPr>
+        <p:txBody>
+          <a:bodyPr/>
+          <a:p/>
+        </p:txBody>
       </p:sp>
       <p:sp>
         <p:nvSpPr>
@@ -26774,6 +27878,10 @@
             <a:prstDash val="solid"/>
           </a:ln>
         </p:spPr>
+        <p:txBody>
+          <a:bodyPr/>
+          <a:p/>
+        </p:txBody>
       </p:sp>
       <p:sp>
         <p:nvSpPr>
@@ -26799,6 +27907,10 @@
             <a:prstDash val="solid"/>
           </a:ln>
         </p:spPr>
+        <p:txBody>
+          <a:bodyPr/>
+          <a:p/>
+        </p:txBody>
       </p:sp>
       <p:sp>
         <p:nvSpPr>
@@ -26902,6 +28014,10 @@
             <a:prstDash val="solid"/>
           </a:ln>
         </p:spPr>
+        <p:txBody>
+          <a:bodyPr/>
+          <a:p/>
+        </p:txBody>
       </p:sp>
       <p:sp>
         <p:nvSpPr>
@@ -26966,6 +28082,10 @@
             <a:prstDash val="solid"/>
           </a:ln>
         </p:spPr>
+        <p:txBody>
+          <a:bodyPr/>
+          <a:p/>
+        </p:txBody>
       </p:sp>
       <p:sp>
         <p:nvSpPr>
@@ -27030,6 +28150,10 @@
             <a:prstDash val="solid"/>
           </a:ln>
         </p:spPr>
+        <p:txBody>
+          <a:bodyPr/>
+          <a:p/>
+        </p:txBody>
       </p:sp>
       <p:sp>
         <p:nvSpPr>
@@ -27092,6 +28216,10 @@
             <a:prstDash val="solid"/>
           </a:ln>
         </p:spPr>
+        <p:txBody>
+          <a:bodyPr/>
+          <a:p/>
+        </p:txBody>
       </p:sp>
       <p:sp>
         <p:nvSpPr>
@@ -27115,6 +28243,10 @@
             <a:prstDash val="solid"/>
           </a:ln>
         </p:spPr>
+        <p:txBody>
+          <a:bodyPr/>
+          <a:p/>
+        </p:txBody>
       </p:sp>
       <p:sp>
         <p:nvSpPr>
@@ -27138,6 +28270,10 @@
             <a:prstDash val="solid"/>
           </a:ln>
         </p:spPr>
+        <p:txBody>
+          <a:bodyPr/>
+          <a:p/>
+        </p:txBody>
       </p:sp>
       <p:sp>
         <p:nvSpPr>
@@ -27161,6 +28297,10 @@
             <a:prstDash val="solid"/>
           </a:ln>
         </p:spPr>
+        <p:txBody>
+          <a:bodyPr/>
+          <a:p/>
+        </p:txBody>
       </p:sp>
       <p:sp>
         <p:nvSpPr>
@@ -27184,6 +28324,10 @@
             <a:prstDash val="solid"/>
           </a:ln>
         </p:spPr>
+        <p:txBody>
+          <a:bodyPr/>
+          <a:p/>
+        </p:txBody>
       </p:sp>
       <p:sp>
         <p:nvSpPr>
@@ -27207,6 +28351,10 @@
             <a:prstDash val="solid"/>
           </a:ln>
         </p:spPr>
+        <p:txBody>
+          <a:bodyPr/>
+          <a:p/>
+        </p:txBody>
       </p:sp>
       <p:sp>
         <p:nvSpPr>
@@ -27230,6 +28378,10 @@
             <a:prstDash val="solid"/>
           </a:ln>
         </p:spPr>
+        <p:txBody>
+          <a:bodyPr/>
+          <a:p/>
+        </p:txBody>
       </p:sp>
       <p:sp>
         <p:nvSpPr>
@@ -27253,6 +28405,10 @@
             <a:prstDash val="solid"/>
           </a:ln>
         </p:spPr>
+        <p:txBody>
+          <a:bodyPr/>
+          <a:p/>
+        </p:txBody>
       </p:sp>
       <p:sp>
         <p:nvSpPr>
@@ -27276,6 +28432,10 @@
             <a:prstDash val="solid"/>
           </a:ln>
         </p:spPr>
+        <p:txBody>
+          <a:bodyPr/>
+          <a:p/>
+        </p:txBody>
       </p:sp>
       <p:sp>
         <p:nvSpPr>
@@ -27299,6 +28459,10 @@
             <a:prstDash val="solid"/>
           </a:ln>
         </p:spPr>
+        <p:txBody>
+          <a:bodyPr/>
+          <a:p/>
+        </p:txBody>
       </p:sp>
       <p:sp>
         <p:nvSpPr>
@@ -27322,6 +28486,10 @@
             <a:prstDash val="solid"/>
           </a:ln>
         </p:spPr>
+        <p:txBody>
+          <a:bodyPr/>
+          <a:p/>
+        </p:txBody>
       </p:sp>
       <p:sp>
         <p:nvSpPr>
@@ -27345,6 +28513,10 @@
             <a:prstDash val="solid"/>
           </a:ln>
         </p:spPr>
+        <p:txBody>
+          <a:bodyPr/>
+          <a:p/>
+        </p:txBody>
       </p:sp>
       <p:sp>
         <p:nvSpPr>
@@ -27368,6 +28540,10 @@
             <a:prstDash val="solid"/>
           </a:ln>
         </p:spPr>
+        <p:txBody>
+          <a:bodyPr/>
+          <a:p/>
+        </p:txBody>
       </p:sp>
       <p:sp>
         <p:nvSpPr>
@@ -27391,6 +28567,10 @@
             <a:prstDash val="solid"/>
           </a:ln>
         </p:spPr>
+        <p:txBody>
+          <a:bodyPr/>
+          <a:p/>
+        </p:txBody>
       </p:sp>
       <p:sp>
         <p:nvSpPr>
@@ -27414,6 +28594,10 @@
             <a:prstDash val="solid"/>
           </a:ln>
         </p:spPr>
+        <p:txBody>
+          <a:bodyPr/>
+          <a:p/>
+        </p:txBody>
       </p:sp>
       <p:sp>
         <p:nvSpPr>
@@ -27437,6 +28621,10 @@
             <a:prstDash val="solid"/>
           </a:ln>
         </p:spPr>
+        <p:txBody>
+          <a:bodyPr/>
+          <a:p/>
+        </p:txBody>
       </p:sp>
       <p:sp>
         <p:nvSpPr>
@@ -27460,6 +28648,10 @@
             <a:prstDash val="solid"/>
           </a:ln>
         </p:spPr>
+        <p:txBody>
+          <a:bodyPr/>
+          <a:p/>
+        </p:txBody>
       </p:sp>
       <p:sp>
         <p:nvSpPr>
@@ -27483,6 +28675,10 @@
             <a:prstDash val="solid"/>
           </a:ln>
         </p:spPr>
+        <p:txBody>
+          <a:bodyPr/>
+          <a:p/>
+        </p:txBody>
       </p:sp>
       <p:sp>
         <p:nvSpPr>
@@ -27506,6 +28702,10 @@
             <a:prstDash val="solid"/>
           </a:ln>
         </p:spPr>
+        <p:txBody>
+          <a:bodyPr/>
+          <a:p/>
+        </p:txBody>
       </p:sp>
       <p:sp>
         <p:nvSpPr>
@@ -27529,6 +28729,10 @@
             <a:prstDash val="solid"/>
           </a:ln>
         </p:spPr>
+        <p:txBody>
+          <a:bodyPr/>
+          <a:p/>
+        </p:txBody>
       </p:sp>
       <p:sp>
         <p:nvSpPr>
@@ -27552,6 +28756,10 @@
             <a:prstDash val="solid"/>
           </a:ln>
         </p:spPr>
+        <p:txBody>
+          <a:bodyPr/>
+          <a:p/>
+        </p:txBody>
       </p:sp>
       <p:sp>
         <p:nvSpPr>
@@ -27575,6 +28783,10 @@
             <a:prstDash val="solid"/>
           </a:ln>
         </p:spPr>
+        <p:txBody>
+          <a:bodyPr/>
+          <a:p/>
+        </p:txBody>
       </p:sp>
       <p:sp>
         <p:nvSpPr>
@@ -27598,6 +28810,10 @@
             <a:prstDash val="solid"/>
           </a:ln>
         </p:spPr>
+        <p:txBody>
+          <a:bodyPr/>
+          <a:p/>
+        </p:txBody>
       </p:sp>
       <p:sp>
         <p:nvSpPr>
@@ -27621,6 +28837,10 @@
             <a:prstDash val="solid"/>
           </a:ln>
         </p:spPr>
+        <p:txBody>
+          <a:bodyPr/>
+          <a:p/>
+        </p:txBody>
       </p:sp>
       <p:sp>
         <p:nvSpPr>
@@ -27644,6 +28864,10 @@
             <a:prstDash val="solid"/>
           </a:ln>
         </p:spPr>
+        <p:txBody>
+          <a:bodyPr/>
+          <a:p/>
+        </p:txBody>
       </p:sp>
       <p:sp>
         <p:nvSpPr>
@@ -27667,6 +28891,10 @@
             <a:prstDash val="solid"/>
           </a:ln>
         </p:spPr>
+        <p:txBody>
+          <a:bodyPr/>
+          <a:p/>
+        </p:txBody>
       </p:sp>
       <p:sp>
         <p:nvSpPr>
@@ -27690,6 +28918,10 @@
             <a:prstDash val="solid"/>
           </a:ln>
         </p:spPr>
+        <p:txBody>
+          <a:bodyPr/>
+          <a:p/>
+        </p:txBody>
       </p:sp>
       <p:sp>
         <p:nvSpPr>
@@ -27713,6 +28945,10 @@
             <a:prstDash val="solid"/>
           </a:ln>
         </p:spPr>
+        <p:txBody>
+          <a:bodyPr/>
+          <a:p/>
+        </p:txBody>
       </p:sp>
       <p:sp>
         <p:nvSpPr>
@@ -27736,6 +28972,10 @@
             <a:prstDash val="solid"/>
           </a:ln>
         </p:spPr>
+        <p:txBody>
+          <a:bodyPr/>
+          <a:p/>
+        </p:txBody>
       </p:sp>
       <p:sp>
         <p:nvSpPr>
@@ -27759,6 +28999,10 @@
             <a:prstDash val="solid"/>
           </a:ln>
         </p:spPr>
+        <p:txBody>
+          <a:bodyPr/>
+          <a:p/>
+        </p:txBody>
       </p:sp>
       <p:sp>
         <p:nvSpPr>
@@ -27782,6 +29026,10 @@
             <a:prstDash val="solid"/>
           </a:ln>
         </p:spPr>
+        <p:txBody>
+          <a:bodyPr/>
+          <a:p/>
+        </p:txBody>
       </p:sp>
       <p:sp>
         <p:nvSpPr>
@@ -27805,6 +29053,10 @@
             <a:prstDash val="solid"/>
           </a:ln>
         </p:spPr>
+        <p:txBody>
+          <a:bodyPr/>
+          <a:p/>
+        </p:txBody>
       </p:sp>
       <p:sp>
         <p:nvSpPr>
@@ -27828,6 +29080,10 @@
             <a:prstDash val="solid"/>
           </a:ln>
         </p:spPr>
+        <p:txBody>
+          <a:bodyPr/>
+          <a:p/>
+        </p:txBody>
       </p:sp>
       <p:sp>
         <p:nvSpPr>
@@ -27851,6 +29107,10 @@
             <a:prstDash val="solid"/>
           </a:ln>
         </p:spPr>
+        <p:txBody>
+          <a:bodyPr/>
+          <a:p/>
+        </p:txBody>
       </p:sp>
       <p:sp>
         <p:nvSpPr>
@@ -27874,6 +29134,10 @@
             <a:prstDash val="solid"/>
           </a:ln>
         </p:spPr>
+        <p:txBody>
+          <a:bodyPr/>
+          <a:p/>
+        </p:txBody>
       </p:sp>
       <p:sp>
         <p:nvSpPr>
@@ -27897,6 +29161,10 @@
             <a:prstDash val="solid"/>
           </a:ln>
         </p:spPr>
+        <p:txBody>
+          <a:bodyPr/>
+          <a:p/>
+        </p:txBody>
       </p:sp>
       <p:sp>
         <p:nvSpPr>
@@ -27920,6 +29188,10 @@
             <a:prstDash val="solid"/>
           </a:ln>
         </p:spPr>
+        <p:txBody>
+          <a:bodyPr/>
+          <a:p/>
+        </p:txBody>
       </p:sp>
       <p:sp>
         <p:nvSpPr>
@@ -27943,6 +29215,10 @@
             <a:prstDash val="solid"/>
           </a:ln>
         </p:spPr>
+        <p:txBody>
+          <a:bodyPr/>
+          <a:p/>
+        </p:txBody>
       </p:sp>
       <p:sp>
         <p:nvSpPr>
@@ -27966,6 +29242,10 @@
             <a:prstDash val="solid"/>
           </a:ln>
         </p:spPr>
+        <p:txBody>
+          <a:bodyPr/>
+          <a:p/>
+        </p:txBody>
       </p:sp>
       <p:sp>
         <p:nvSpPr>
@@ -27989,6 +29269,10 @@
             <a:prstDash val="solid"/>
           </a:ln>
         </p:spPr>
+        <p:txBody>
+          <a:bodyPr/>
+          <a:p/>
+        </p:txBody>
       </p:sp>
       <p:sp>
         <p:nvSpPr>
@@ -28012,6 +29296,10 @@
             <a:prstDash val="solid"/>
           </a:ln>
         </p:spPr>
+        <p:txBody>
+          <a:bodyPr/>
+          <a:p/>
+        </p:txBody>
       </p:sp>
       <p:sp>
         <p:nvSpPr>
@@ -28035,6 +29323,10 @@
             <a:prstDash val="solid"/>
           </a:ln>
         </p:spPr>
+        <p:txBody>
+          <a:bodyPr/>
+          <a:p/>
+        </p:txBody>
       </p:sp>
       <p:sp>
         <p:nvSpPr>
@@ -28058,6 +29350,10 @@
             <a:prstDash val="solid"/>
           </a:ln>
         </p:spPr>
+        <p:txBody>
+          <a:bodyPr/>
+          <a:p/>
+        </p:txBody>
       </p:sp>
       <p:sp>
         <p:nvSpPr>
@@ -28081,6 +29377,10 @@
             <a:prstDash val="solid"/>
           </a:ln>
         </p:spPr>
+        <p:txBody>
+          <a:bodyPr/>
+          <a:p/>
+        </p:txBody>
       </p:sp>
       <p:sp>
         <p:nvSpPr>
@@ -28104,6 +29404,10 @@
             <a:prstDash val="solid"/>
           </a:ln>
         </p:spPr>
+        <p:txBody>
+          <a:bodyPr/>
+          <a:p/>
+        </p:txBody>
       </p:sp>
       <p:sp>
         <p:nvSpPr>
@@ -28127,6 +29431,10 @@
             <a:prstDash val="solid"/>
           </a:ln>
         </p:spPr>
+        <p:txBody>
+          <a:bodyPr/>
+          <a:p/>
+        </p:txBody>
       </p:sp>
       <p:sp>
         <p:nvSpPr>
@@ -28150,6 +29458,10 @@
             <a:prstDash val="solid"/>
           </a:ln>
         </p:spPr>
+        <p:txBody>
+          <a:bodyPr/>
+          <a:p/>
+        </p:txBody>
       </p:sp>
       <p:sp>
         <p:nvSpPr>
@@ -28173,6 +29485,10 @@
             <a:prstDash val="solid"/>
           </a:ln>
         </p:spPr>
+        <p:txBody>
+          <a:bodyPr/>
+          <a:p/>
+        </p:txBody>
       </p:sp>
       <p:sp>
         <p:nvSpPr>
@@ -28356,6 +29672,10 @@
             <a:prstDash val="solid"/>
           </a:ln>
         </p:spPr>
+        <p:txBody>
+          <a:bodyPr/>
+          <a:p/>
+        </p:txBody>
       </p:sp>
       <p:sp>
         <p:nvSpPr>
@@ -28454,6 +29774,10 @@
             <a:prstDash val="solid"/>
           </a:ln>
         </p:spPr>
+        <p:txBody>
+          <a:bodyPr/>
+          <a:p/>
+        </p:txBody>
       </p:sp>
       <p:sp>
         <p:nvSpPr>
@@ -28598,6 +29922,10 @@
             <a:prstDash val="solid"/>
           </a:ln>
         </p:spPr>
+        <p:txBody>
+          <a:bodyPr/>
+          <a:p/>
+        </p:txBody>
       </p:sp>
       <p:sp>
         <p:nvSpPr>
@@ -28664,6 +29992,10 @@
             <a:prstDash val="solid"/>
           </a:ln>
         </p:spPr>
+        <p:txBody>
+          <a:bodyPr/>
+          <a:p/>
+        </p:txBody>
       </p:sp>
       <p:sp>
         <p:nvSpPr>
@@ -28730,6 +30062,10 @@
             <a:prstDash val="solid"/>
           </a:ln>
         </p:spPr>
+        <p:txBody>
+          <a:bodyPr/>
+          <a:p/>
+        </p:txBody>
       </p:sp>
       <p:sp>
         <p:nvSpPr>
@@ -28796,6 +30132,10 @@
             <a:prstDash val="solid"/>
           </a:ln>
         </p:spPr>
+        <p:txBody>
+          <a:bodyPr/>
+          <a:p/>
+        </p:txBody>
       </p:sp>
       <p:sp>
         <p:nvSpPr>
@@ -28862,6 +30202,10 @@
             <a:prstDash val="solid"/>
           </a:ln>
         </p:spPr>
+        <p:txBody>
+          <a:bodyPr/>
+          <a:p/>
+        </p:txBody>
       </p:sp>
       <p:sp>
         <p:nvSpPr>
@@ -28928,6 +30272,10 @@
             <a:prstDash val="solid"/>
           </a:ln>
         </p:spPr>
+        <p:txBody>
+          <a:bodyPr/>
+          <a:p/>
+        </p:txBody>
       </p:sp>
       <p:sp>
         <p:nvSpPr>
@@ -28994,6 +30342,10 @@
             <a:prstDash val="solid"/>
           </a:ln>
         </p:spPr>
+        <p:txBody>
+          <a:bodyPr/>
+          <a:p/>
+        </p:txBody>
       </p:sp>
       <p:sp>
         <p:nvSpPr>
@@ -29168,6 +30520,10 @@
             <a:prstDash val="solid"/>
           </a:ln>
         </p:spPr>
+        <p:txBody>
+          <a:bodyPr/>
+          <a:p/>
+        </p:txBody>
       </p:sp>
       <p:sp>
         <p:nvSpPr>
@@ -29193,6 +30549,10 @@
             <a:prstDash val="solid"/>
           </a:ln>
         </p:spPr>
+        <p:txBody>
+          <a:bodyPr/>
+          <a:p/>
+        </p:txBody>
       </p:sp>
       <p:sp>
         <p:nvSpPr>
@@ -29335,6 +30695,10 @@
             <a:prstDash val="solid"/>
           </a:ln>
         </p:spPr>
+        <p:txBody>
+          <a:bodyPr/>
+          <a:p/>
+        </p:txBody>
       </p:sp>
       <p:sp>
         <p:nvSpPr>
@@ -29477,6 +30841,10 @@
             <a:prstDash val="solid"/>
           </a:ln>
         </p:spPr>
+        <p:txBody>
+          <a:bodyPr/>
+          <a:p/>
+        </p:txBody>
       </p:sp>
       <p:sp>
         <p:nvSpPr>
@@ -29619,6 +30987,10 @@
             <a:prstDash val="solid"/>
           </a:ln>
         </p:spPr>
+        <p:txBody>
+          <a:bodyPr/>
+          <a:p/>
+        </p:txBody>
       </p:sp>
       <p:sp>
         <p:nvSpPr>
@@ -29761,6 +31133,10 @@
             <a:prstDash val="solid"/>
           </a:ln>
         </p:spPr>
+        <p:txBody>
+          <a:bodyPr/>
+          <a:p/>
+        </p:txBody>
       </p:sp>
       <p:sp>
         <p:nvSpPr>
@@ -29903,6 +31279,10 @@
             <a:prstDash val="solid"/>
           </a:ln>
         </p:spPr>
+        <p:txBody>
+          <a:bodyPr/>
+          <a:p/>
+        </p:txBody>
       </p:sp>
       <p:sp>
         <p:nvSpPr>
@@ -30045,6 +31425,10 @@
             <a:prstDash val="solid"/>
           </a:ln>
         </p:spPr>
+        <p:txBody>
+          <a:bodyPr/>
+          <a:p/>
+        </p:txBody>
       </p:sp>
       <p:sp>
         <p:nvSpPr>
@@ -30189,6 +31573,10 @@
             <a:prstDash val="solid"/>
           </a:ln>
         </p:spPr>
+        <p:txBody>
+          <a:bodyPr/>
+          <a:p/>
+        </p:txBody>
       </p:sp>
       <p:sp>
         <p:nvSpPr>
@@ -30326,6 +31714,10 @@
             <a:prstDash val="solid"/>
           </a:ln>
         </p:spPr>
+        <p:txBody>
+          <a:bodyPr/>
+          <a:p/>
+        </p:txBody>
       </p:sp>
       <p:sp>
         <p:nvSpPr>
@@ -30470,6 +31862,10 @@
             <a:prstDash val="solid"/>
           </a:ln>
         </p:spPr>
+        <p:txBody>
+          <a:bodyPr/>
+          <a:p/>
+        </p:txBody>
       </p:sp>
       <p:sp>
         <p:nvSpPr>
@@ -30490,6 +31886,10 @@
           </a:solidFill>
           <a:ln/>
         </p:spPr>
+        <p:txBody>
+          <a:bodyPr/>
+          <a:p/>
+        </p:txBody>
       </p:sp>
       <p:sp>
         <p:nvSpPr>
@@ -30595,6 +31995,10 @@
             <a:prstDash val="solid"/>
           </a:ln>
         </p:spPr>
+        <p:txBody>
+          <a:bodyPr/>
+          <a:p/>
+        </p:txBody>
       </p:sp>
       <p:sp>
         <p:nvSpPr>
@@ -30615,6 +32019,10 @@
           </a:solidFill>
           <a:ln/>
         </p:spPr>
+        <p:txBody>
+          <a:bodyPr/>
+          <a:p/>
+        </p:txBody>
       </p:sp>
       <p:sp>
         <p:nvSpPr>
@@ -30720,6 +32128,10 @@
             <a:prstDash val="solid"/>
           </a:ln>
         </p:spPr>
+        <p:txBody>
+          <a:bodyPr/>
+          <a:p/>
+        </p:txBody>
       </p:sp>
       <p:sp>
         <p:nvSpPr>
@@ -30740,6 +32152,10 @@
           </a:solidFill>
           <a:ln/>
         </p:spPr>
+        <p:txBody>
+          <a:bodyPr/>
+          <a:p/>
+        </p:txBody>
       </p:sp>
       <p:sp>
         <p:nvSpPr>
@@ -30845,6 +32261,10 @@
             <a:prstDash val="solid"/>
           </a:ln>
         </p:spPr>
+        <p:txBody>
+          <a:bodyPr/>
+          <a:p/>
+        </p:txBody>
       </p:sp>
       <p:sp>
         <p:nvSpPr>
@@ -30865,6 +32285,10 @@
           </a:solidFill>
           <a:ln/>
         </p:spPr>
+        <p:txBody>
+          <a:bodyPr/>
+          <a:p/>
+        </p:txBody>
       </p:sp>
       <p:sp>
         <p:nvSpPr>
@@ -30970,6 +32394,10 @@
             <a:prstDash val="solid"/>
           </a:ln>
         </p:spPr>
+        <p:txBody>
+          <a:bodyPr/>
+          <a:p/>
+        </p:txBody>
       </p:sp>
       <p:sp>
         <p:nvSpPr>
@@ -31256,6 +32684,10 @@
             <a:prstDash val="solid"/>
           </a:ln>
         </p:spPr>
+        <p:txBody>
+          <a:bodyPr/>
+          <a:p/>
+        </p:txBody>
       </p:sp>
       <p:sp>
         <p:nvSpPr>
@@ -31439,6 +32871,10 @@
             <a:prstDash val="solid"/>
           </a:ln>
         </p:spPr>
+        <p:txBody>
+          <a:bodyPr/>
+          <a:p/>
+        </p:txBody>
       </p:sp>
       <p:sp>
         <p:nvSpPr>
@@ -31576,6 +33012,10 @@
             <a:prstDash val="solid"/>
           </a:ln>
         </p:spPr>
+        <p:txBody>
+          <a:bodyPr/>
+          <a:p/>
+        </p:txBody>
       </p:sp>
       <p:sp>
         <p:nvSpPr>
@@ -31674,6 +33114,10 @@
           </a:solidFill>
           <a:ln/>
         </p:spPr>
+        <p:txBody>
+          <a:bodyPr/>
+          <a:p/>
+        </p:txBody>
       </p:sp>
       <p:sp>
         <p:nvSpPr>
@@ -31772,6 +33216,10 @@
           </a:solidFill>
           <a:ln/>
         </p:spPr>
+        <p:txBody>
+          <a:bodyPr/>
+          <a:p/>
+        </p:txBody>
       </p:sp>
       <p:sp>
         <p:nvSpPr>
@@ -31870,6 +33318,10 @@
           </a:solidFill>
           <a:ln/>
         </p:spPr>
+        <p:txBody>
+          <a:bodyPr/>
+          <a:p/>
+        </p:txBody>
       </p:sp>
       <p:sp>
         <p:nvSpPr>
@@ -31975,6 +33427,10 @@
             <a:prstDash val="solid"/>
           </a:ln>
         </p:spPr>
+        <p:txBody>
+          <a:bodyPr/>
+          <a:p/>
+        </p:txBody>
       </p:sp>
       <p:sp>
         <p:nvSpPr>
@@ -32112,6 +33568,10 @@
             <a:prstDash val="solid"/>
           </a:ln>
         </p:spPr>
+        <p:txBody>
+          <a:bodyPr/>
+          <a:p/>
+        </p:txBody>
       </p:sp>
       <p:sp>
         <p:nvSpPr>
@@ -32256,6 +33716,10 @@
             <a:prstDash val="solid"/>
           </a:ln>
         </p:spPr>
+        <p:txBody>
+          <a:bodyPr/>
+          <a:p/>
+        </p:txBody>
       </p:sp>
       <p:sp>
         <p:nvSpPr>
@@ -32276,6 +33740,10 @@
           </a:solidFill>
           <a:ln/>
         </p:spPr>
+        <p:txBody>
+          <a:bodyPr/>
+          <a:p/>
+        </p:txBody>
       </p:sp>
       <p:sp>
         <p:nvSpPr>
@@ -32381,6 +33849,10 @@
             <a:prstDash val="solid"/>
           </a:ln>
         </p:spPr>
+        <p:txBody>
+          <a:bodyPr/>
+          <a:p/>
+        </p:txBody>
       </p:sp>
       <p:sp>
         <p:nvSpPr>
@@ -32401,6 +33873,10 @@
           </a:solidFill>
           <a:ln/>
         </p:spPr>
+        <p:txBody>
+          <a:bodyPr/>
+          <a:p/>
+        </p:txBody>
       </p:sp>
       <p:sp>
         <p:nvSpPr>
@@ -32506,6 +33982,10 @@
             <a:prstDash val="solid"/>
           </a:ln>
         </p:spPr>
+        <p:txBody>
+          <a:bodyPr/>
+          <a:p/>
+        </p:txBody>
       </p:sp>
       <p:sp>
         <p:nvSpPr>
@@ -32526,6 +34006,10 @@
           </a:solidFill>
           <a:ln/>
         </p:spPr>
+        <p:txBody>
+          <a:bodyPr/>
+          <a:p/>
+        </p:txBody>
       </p:sp>
       <p:sp>
         <p:nvSpPr>
@@ -32631,6 +34115,10 @@
             <a:prstDash val="solid"/>
           </a:ln>
         </p:spPr>
+        <p:txBody>
+          <a:bodyPr/>
+          <a:p/>
+        </p:txBody>
       </p:sp>
       <p:sp>
         <p:nvSpPr>
@@ -32651,6 +34139,10 @@
           </a:solidFill>
           <a:ln/>
         </p:spPr>
+        <p:txBody>
+          <a:bodyPr/>
+          <a:p/>
+        </p:txBody>
       </p:sp>
       <p:sp>
         <p:nvSpPr>
@@ -32756,6 +34248,10 @@
             <a:prstDash val="solid"/>
           </a:ln>
         </p:spPr>
+        <p:txBody>
+          <a:bodyPr/>
+          <a:p/>
+        </p:txBody>
       </p:sp>
       <p:sp>
         <p:nvSpPr>
@@ -32893,6 +34389,10 @@
             <a:prstDash val="solid"/>
           </a:ln>
         </p:spPr>
+        <p:txBody>
+          <a:bodyPr/>
+          <a:p/>
+        </p:txBody>
       </p:sp>
       <p:sp>
         <p:nvSpPr>
@@ -33074,6 +34574,10 @@
             <a:prstDash val="solid"/>
           </a:ln>
         </p:spPr>
+        <p:txBody>
+          <a:bodyPr/>
+          <a:p/>
+        </p:txBody>
       </p:sp>
     </p:spTree>
   </p:cSld>
@@ -33250,6 +34754,10 @@
             <a:prstDash val="solid"/>
           </a:ln>
         </p:spPr>
+        <p:txBody>
+          <a:bodyPr/>
+          <a:p/>
+        </p:txBody>
       </p:sp>
       <p:sp>
         <p:nvSpPr>
@@ -33275,6 +34783,10 @@
             <a:prstDash val="solid"/>
           </a:ln>
         </p:spPr>
+        <p:txBody>
+          <a:bodyPr/>
+          <a:p/>
+        </p:txBody>
       </p:sp>
       <p:sp>
         <p:nvSpPr>
@@ -33380,6 +34892,10 @@
             <a:prstDash val="solid"/>
           </a:ln>
         </p:spPr>
+        <p:txBody>
+          <a:bodyPr/>
+          <a:p/>
+        </p:txBody>
       </p:sp>
       <p:sp>
         <p:nvSpPr>
@@ -33405,6 +34921,10 @@
             <a:prstDash val="solid"/>
           </a:ln>
         </p:spPr>
+        <p:txBody>
+          <a:bodyPr/>
+          <a:p/>
+        </p:txBody>
       </p:sp>
       <p:sp>
         <p:nvSpPr>
@@ -33510,6 +35030,10 @@
             <a:prstDash val="solid"/>
           </a:ln>
         </p:spPr>
+        <p:txBody>
+          <a:bodyPr/>
+          <a:p/>
+        </p:txBody>
       </p:sp>
       <p:sp>
         <p:nvSpPr>
@@ -33535,6 +35059,10 @@
             <a:prstDash val="solid"/>
           </a:ln>
         </p:spPr>
+        <p:txBody>
+          <a:bodyPr/>
+          <a:p/>
+        </p:txBody>
       </p:sp>
       <p:sp>
         <p:nvSpPr>
@@ -33640,6 +35168,10 @@
             <a:prstDash val="solid"/>
           </a:ln>
         </p:spPr>
+        <p:txBody>
+          <a:bodyPr/>
+          <a:p/>
+        </p:txBody>
       </p:sp>
       <p:sp>
         <p:nvSpPr>
@@ -33777,6 +35309,10 @@
             <a:prstDash val="solid"/>
           </a:ln>
         </p:spPr>
+        <p:txBody>
+          <a:bodyPr/>
+          <a:p/>
+        </p:txBody>
       </p:sp>
       <p:sp>
         <p:nvSpPr>
@@ -33921,6 +35457,10 @@
             <a:prstDash val="solid"/>
           </a:ln>
         </p:spPr>
+        <p:txBody>
+          <a:bodyPr/>
+          <a:p/>
+        </p:txBody>
       </p:sp>
       <p:sp>
         <p:nvSpPr>
@@ -34175,6 +35715,10 @@
             <a:prstDash val="solid"/>
           </a:ln>
         </p:spPr>
+        <p:txBody>
+          <a:bodyPr/>
+          <a:p/>
+        </p:txBody>
       </p:sp>
       <p:sp>
         <p:nvSpPr>
@@ -34200,6 +35744,10 @@
             <a:prstDash val="solid"/>
           </a:ln>
         </p:spPr>
+        <p:txBody>
+          <a:bodyPr/>
+          <a:p/>
+        </p:txBody>
       </p:sp>
       <p:sp>
         <p:nvSpPr>
@@ -34305,6 +35853,10 @@
             <a:prstDash val="solid"/>
           </a:ln>
         </p:spPr>
+        <p:txBody>
+          <a:bodyPr/>
+          <a:p/>
+        </p:txBody>
       </p:sp>
       <p:sp>
         <p:nvSpPr>
@@ -34330,6 +35882,10 @@
             <a:prstDash val="solid"/>
           </a:ln>
         </p:spPr>
+        <p:txBody>
+          <a:bodyPr/>
+          <a:p/>
+        </p:txBody>
       </p:sp>
       <p:sp>
         <p:nvSpPr>
@@ -34435,6 +35991,10 @@
             <a:prstDash val="solid"/>
           </a:ln>
         </p:spPr>
+        <p:txBody>
+          <a:bodyPr/>
+          <a:p/>
+        </p:txBody>
       </p:sp>
       <p:sp>
         <p:nvSpPr>
@@ -34460,6 +36020,10 @@
             <a:prstDash val="solid"/>
           </a:ln>
         </p:spPr>
+        <p:txBody>
+          <a:bodyPr/>
+          <a:p/>
+        </p:txBody>
       </p:sp>
       <p:sp>
         <p:nvSpPr>
@@ -34565,6 +36129,10 @@
             <a:prstDash val="solid"/>
           </a:ln>
         </p:spPr>
+        <p:txBody>
+          <a:bodyPr/>
+          <a:p/>
+        </p:txBody>
       </p:sp>
       <p:sp>
         <p:nvSpPr>

</xml_diff>